<commit_message>
Site: deck branding and a landing page with the value items
Restyle the dashboard and value case in the deck's palette (navy, cloud
blue, orange for the problem cohort). New landing page at / lists the
three value items, the approach and the resources; the dashboard moves
to /dashboard.html and both decks are published as PDFs. Deck links and
README updated to match.

Co-Authored-By: Claude Opus 5.5 <noreply@anthropic.com>
</commit_message>
<xml_diff>
--- a/deck/salesforce-process-intelligence-tech-setup.pptx
+++ b/deck/salesforce-process-intelligence-tech-setup.pptx
@@ -109,7 +109,7 @@
   <p:extLst>
     <p:ext uri="{521415D9-36F7-43E2-AB2F-B90AF26B5E84}">
       <p14:sectionLst xmlns:p14="http://schemas.microsoft.com/office/powerpoint/2010/main">
-        <p14:section name="Tech setup" id="{1327d122-50ea-de0c-729f-467afe7d2a0c}">
+        <p14:section name="Tech setup" id="{535c22b5-914e-55bb-2a51-95b7c26de441}">
           <p14:sldIdLst>
             <p14:sldId id="256"/>
             <p14:sldId id="257"/>
@@ -3838,12 +3838,12 @@
         </p:nvSpPr>
         <p:spPr>
           <a:xfrm>
-            <a:off x="548640" y="1417320"/>
-            <a:ext cx="6035040" cy="960120"/>
+            <a:off x="548640" y="1371600"/>
+            <a:ext cx="6035040" cy="804672"/>
           </a:xfrm>
           <a:prstGeom prst="roundRect">
             <a:avLst>
-              <a:gd name="adj" fmla="val 11429"/>
+              <a:gd name="adj" fmla="val 13636"/>
             </a:avLst>
           </a:prstGeom>
           <a:solidFill>
@@ -3860,7 +3860,7 @@
         </p:nvSpPr>
         <p:spPr>
           <a:xfrm>
-            <a:off x="749808" y="1691640"/>
+            <a:off x="749808" y="1554480"/>
             <a:ext cx="411480" cy="411480"/>
           </a:xfrm>
           <a:prstGeom prst="ellipse">
@@ -3880,7 +3880,7 @@
         </p:nvSpPr>
         <p:spPr>
           <a:xfrm>
-            <a:off x="749808" y="1691640"/>
+            <a:off x="749808" y="1554480"/>
             <a:ext cx="411480" cy="411480"/>
           </a:xfrm>
           <a:prstGeom prst="rect">
@@ -3916,8 +3916,8 @@
         </p:nvSpPr>
         <p:spPr>
           <a:xfrm>
-            <a:off x="1325880" y="1545336"/>
-            <a:ext cx="5120640" cy="347472"/>
+            <a:off x="1325880" y="1444752"/>
+            <a:ext cx="5120640" cy="329184"/>
           </a:xfrm>
           <a:prstGeom prst="rect">
             <a:avLst/>
@@ -3938,7 +3938,7 @@
                   <a:schemeClr val="tx2"/>
                 </a:solidFill>
               </a:rPr>
-              <a:t>Process dashboard</a:t>
+              <a:t>Landing page and value items</a:t>
             </a:r>
             <a:endParaRPr lang="en-US" sz="1600" dirty="0"/>
           </a:p>
@@ -3952,8 +3952,8 @@
         </p:nvSpPr>
         <p:spPr>
           <a:xfrm>
-            <a:off x="1325880" y="1911096"/>
-            <a:ext cx="5120640" cy="347472"/>
+            <a:off x="1325880" y="1792224"/>
+            <a:ext cx="5120640" cy="310896"/>
           </a:xfrm>
           <a:prstGeom prst="rect">
             <a:avLst/>
@@ -3995,12 +3995,12 @@
         </p:nvSpPr>
         <p:spPr>
           <a:xfrm>
-            <a:off x="548640" y="2532888"/>
-            <a:ext cx="6035040" cy="960120"/>
+            <a:off x="548640" y="2286000"/>
+            <a:ext cx="6035040" cy="804672"/>
           </a:xfrm>
           <a:prstGeom prst="roundRect">
             <a:avLst>
-              <a:gd name="adj" fmla="val 11429"/>
+              <a:gd name="adj" fmla="val 13636"/>
             </a:avLst>
           </a:prstGeom>
           <a:solidFill>
@@ -4017,7 +4017,7 @@
         </p:nvSpPr>
         <p:spPr>
           <a:xfrm>
-            <a:off x="749808" y="2807208"/>
+            <a:off x="749808" y="2468880"/>
             <a:ext cx="411480" cy="411480"/>
           </a:xfrm>
           <a:prstGeom prst="ellipse">
@@ -4037,7 +4037,7 @@
         </p:nvSpPr>
         <p:spPr>
           <a:xfrm>
-            <a:off x="749808" y="2807208"/>
+            <a:off x="749808" y="2468880"/>
             <a:ext cx="411480" cy="411480"/>
           </a:xfrm>
           <a:prstGeom prst="rect">
@@ -4073,8 +4073,8 @@
         </p:nvSpPr>
         <p:spPr>
           <a:xfrm>
-            <a:off x="1325880" y="2660904"/>
-            <a:ext cx="5120640" cy="347472"/>
+            <a:off x="1325880" y="2359152"/>
+            <a:ext cx="5120640" cy="329184"/>
           </a:xfrm>
           <a:prstGeom prst="rect">
             <a:avLst/>
@@ -4095,7 +4095,7 @@
                   <a:schemeClr val="tx2"/>
                 </a:solidFill>
               </a:rPr>
-              <a:t>Value case one-pager</a:t>
+              <a:t>Process dashboard</a:t>
             </a:r>
             <a:endParaRPr lang="en-US" sz="1600" dirty="0"/>
           </a:p>
@@ -4109,8 +4109,8 @@
         </p:nvSpPr>
         <p:spPr>
           <a:xfrm>
-            <a:off x="1325880" y="3026664"/>
-            <a:ext cx="5120640" cy="347472"/>
+            <a:off x="1325880" y="2706624"/>
+            <a:ext cx="5120640" cy="310896"/>
           </a:xfrm>
           <a:prstGeom prst="rect">
             <a:avLst/>
@@ -4138,7 +4138,7 @@
                   </a:extLst>
                 </a:hlinkClick>
               </a:rPr>
-              <a:t>salesforce-process-intelligence.vercel.app/value-case.html</a:t>
+              <a:t>salesforce-process-intelligence.vercel.app/dashboard.html</a:t>
             </a:r>
             <a:endParaRPr lang="en-US" sz="1400" dirty="0"/>
           </a:p>
@@ -4152,12 +4152,12 @@
         </p:nvSpPr>
         <p:spPr>
           <a:xfrm>
-            <a:off x="548640" y="3648456"/>
-            <a:ext cx="6035040" cy="960120"/>
+            <a:off x="548640" y="3200400"/>
+            <a:ext cx="6035040" cy="804672"/>
           </a:xfrm>
           <a:prstGeom prst="roundRect">
             <a:avLst>
-              <a:gd name="adj" fmla="val 11429"/>
+              <a:gd name="adj" fmla="val 13636"/>
             </a:avLst>
           </a:prstGeom>
           <a:solidFill>
@@ -4174,7 +4174,7 @@
         </p:nvSpPr>
         <p:spPr>
           <a:xfrm>
-            <a:off x="749808" y="3922776"/>
+            <a:off x="749808" y="3383280"/>
             <a:ext cx="411480" cy="411480"/>
           </a:xfrm>
           <a:prstGeom prst="ellipse">
@@ -4194,7 +4194,7 @@
         </p:nvSpPr>
         <p:spPr>
           <a:xfrm>
-            <a:off x="749808" y="3922776"/>
+            <a:off x="749808" y="3383280"/>
             <a:ext cx="411480" cy="411480"/>
           </a:xfrm>
           <a:prstGeom prst="rect">
@@ -4230,8 +4230,8 @@
         </p:nvSpPr>
         <p:spPr>
           <a:xfrm>
-            <a:off x="1325880" y="3776472"/>
-            <a:ext cx="5120640" cy="347472"/>
+            <a:off x="1325880" y="3273552"/>
+            <a:ext cx="5120640" cy="329184"/>
           </a:xfrm>
           <a:prstGeom prst="rect">
             <a:avLst/>
@@ -4252,7 +4252,7 @@
                   <a:schemeClr val="tx2"/>
                 </a:solidFill>
               </a:rPr>
-              <a:t>Live Salesforce extract</a:t>
+              <a:t>Value case one-pager</a:t>
             </a:r>
             <a:endParaRPr lang="en-US" sz="1600" dirty="0"/>
           </a:p>
@@ -4266,8 +4266,8 @@
         </p:nvSpPr>
         <p:spPr>
           <a:xfrm>
-            <a:off x="1325880" y="4142232"/>
-            <a:ext cx="5120640" cy="347472"/>
+            <a:off x="1325880" y="3621024"/>
+            <a:ext cx="5120640" cy="310896"/>
           </a:xfrm>
           <a:prstGeom prst="rect">
             <a:avLst/>
@@ -4295,7 +4295,7 @@
                   </a:extLst>
                 </a:hlinkClick>
               </a:rPr>
-              <a:t>salesforce-process-intelligence.vercel.app/live.html</a:t>
+              <a:t>salesforce-process-intelligence.vercel.app/value-case.html</a:t>
             </a:r>
             <a:endParaRPr lang="en-US" sz="1400" dirty="0"/>
           </a:p>
@@ -4309,12 +4309,12 @@
         </p:nvSpPr>
         <p:spPr>
           <a:xfrm>
-            <a:off x="548640" y="4764024"/>
-            <a:ext cx="6035040" cy="960120"/>
+            <a:off x="548640" y="4114800"/>
+            <a:ext cx="6035040" cy="804672"/>
           </a:xfrm>
           <a:prstGeom prst="roundRect">
             <a:avLst>
-              <a:gd name="adj" fmla="val 11429"/>
+              <a:gd name="adj" fmla="val 13636"/>
             </a:avLst>
           </a:prstGeom>
           <a:solidFill>
@@ -4331,7 +4331,7 @@
         </p:nvSpPr>
         <p:spPr>
           <a:xfrm>
-            <a:off x="749808" y="5038344"/>
+            <a:off x="749808" y="4297680"/>
             <a:ext cx="411480" cy="411480"/>
           </a:xfrm>
           <a:prstGeom prst="ellipse">
@@ -4351,7 +4351,7 @@
         </p:nvSpPr>
         <p:spPr>
           <a:xfrm>
-            <a:off x="749808" y="5038344"/>
+            <a:off x="749808" y="4297680"/>
             <a:ext cx="411480" cy="411480"/>
           </a:xfrm>
           <a:prstGeom prst="rect">
@@ -4387,8 +4387,8 @@
         </p:nvSpPr>
         <p:spPr>
           <a:xfrm>
-            <a:off x="1325880" y="4892040"/>
-            <a:ext cx="5120640" cy="347472"/>
+            <a:off x="1325880" y="4187952"/>
+            <a:ext cx="5120640" cy="329184"/>
           </a:xfrm>
           <a:prstGeom prst="rect">
             <a:avLst/>
@@ -4409,7 +4409,7 @@
                   <a:schemeClr val="tx2"/>
                 </a:solidFill>
               </a:rPr>
-              <a:t>Source code and event logs</a:t>
+              <a:t>Live Salesforce extract</a:t>
             </a:r>
             <a:endParaRPr lang="en-US" sz="1600" dirty="0"/>
           </a:p>
@@ -4423,8 +4423,8 @@
         </p:nvSpPr>
         <p:spPr>
           <a:xfrm>
-            <a:off x="1325880" y="5257800"/>
-            <a:ext cx="5120640" cy="347472"/>
+            <a:off x="1325880" y="4535424"/>
+            <a:ext cx="5120640" cy="310896"/>
           </a:xfrm>
           <a:prstGeom prst="rect">
             <a:avLst/>
@@ -4452,6 +4452,163 @@
                   </a:extLst>
                 </a:hlinkClick>
               </a:rPr>
+              <a:t>salesforce-process-intelligence.vercel.app/live.html</a:t>
+            </a:r>
+            <a:endParaRPr lang="en-US" sz="1400" dirty="0"/>
+          </a:p>
+        </p:txBody>
+      </p:sp>
+      <p:sp>
+        <p:nvSpPr>
+          <p:cNvPr id="23" name="Proof 5"/>
+          <p:cNvSpPr/>
+          <p:nvPr/>
+        </p:nvSpPr>
+        <p:spPr>
+          <a:xfrm>
+            <a:off x="548640" y="5029200"/>
+            <a:ext cx="6035040" cy="804672"/>
+          </a:xfrm>
+          <a:prstGeom prst="roundRect">
+            <a:avLst>
+              <a:gd name="adj" fmla="val 13636"/>
+            </a:avLst>
+          </a:prstGeom>
+          <a:solidFill>
+            <a:schemeClr val="bg2"/>
+          </a:solidFill>
+          <a:ln/>
+        </p:spPr>
+      </p:sp>
+      <p:sp>
+        <p:nvSpPr>
+          <p:cNvPr id="24" name="Proof 5 marker"/>
+          <p:cNvSpPr/>
+          <p:nvPr/>
+        </p:nvSpPr>
+        <p:spPr>
+          <a:xfrm>
+            <a:off x="749808" y="5212080"/>
+            <a:ext cx="411480" cy="411480"/>
+          </a:xfrm>
+          <a:prstGeom prst="ellipse">
+            <a:avLst/>
+          </a:prstGeom>
+          <a:solidFill>
+            <a:schemeClr val="accent1"/>
+          </a:solidFill>
+          <a:ln/>
+        </p:spPr>
+      </p:sp>
+      <p:sp>
+        <p:nvSpPr>
+          <p:cNvPr id="25" name="Proof 5 glyph"/>
+          <p:cNvSpPr txBox="1"/>
+          <p:nvPr/>
+        </p:nvSpPr>
+        <p:spPr>
+          <a:xfrm>
+            <a:off x="749808" y="5212080"/>
+            <a:ext cx="411480" cy="411480"/>
+          </a:xfrm>
+          <a:prstGeom prst="rect">
+            <a:avLst/>
+          </a:prstGeom>
+          <a:noFill/>
+          <a:ln/>
+        </p:spPr>
+        <p:txBody>
+          <a:bodyPr wrap="square" lIns="0" tIns="0" rIns="0" bIns="0" rtlCol="0" anchor="ctr"/>
+          <a:lstStyle/>
+          <a:p>
+            <a:pPr algn="ctr" indent="0" marL="0">
+              <a:buNone/>
+            </a:pPr>
+            <a:r>
+              <a:rPr lang="en-US" sz="1600" b="1" dirty="0">
+                <a:solidFill>
+                  <a:schemeClr val="bg1"/>
+                </a:solidFill>
+              </a:rPr>
+              <a:t>→</a:t>
+            </a:r>
+            <a:endParaRPr lang="en-US" sz="1600" dirty="0"/>
+          </a:p>
+        </p:txBody>
+      </p:sp>
+      <p:sp>
+        <p:nvSpPr>
+          <p:cNvPr id="26" name="Proof 5 label"/>
+          <p:cNvSpPr txBox="1"/>
+          <p:nvPr/>
+        </p:nvSpPr>
+        <p:spPr>
+          <a:xfrm>
+            <a:off x="1325880" y="5102352"/>
+            <a:ext cx="5120640" cy="329184"/>
+          </a:xfrm>
+          <a:prstGeom prst="rect">
+            <a:avLst/>
+          </a:prstGeom>
+          <a:noFill/>
+          <a:ln/>
+        </p:spPr>
+        <p:txBody>
+          <a:bodyPr wrap="square" lIns="0" tIns="0" rIns="0" bIns="0" rtlCol="0" anchor="t"/>
+          <a:lstStyle/>
+          <a:p>
+            <a:pPr indent="0" marL="0">
+              <a:buNone/>
+            </a:pPr>
+            <a:r>
+              <a:rPr lang="en-US" sz="1600" b="1" dirty="0">
+                <a:solidFill>
+                  <a:schemeClr val="tx2"/>
+                </a:solidFill>
+              </a:rPr>
+              <a:t>Source code and event logs</a:t>
+            </a:r>
+            <a:endParaRPr lang="en-US" sz="1600" dirty="0"/>
+          </a:p>
+        </p:txBody>
+      </p:sp>
+      <p:sp>
+        <p:nvSpPr>
+          <p:cNvPr id="27" name="Proof 5 link"/>
+          <p:cNvSpPr txBox="1"/>
+          <p:nvPr/>
+        </p:nvSpPr>
+        <p:spPr>
+          <a:xfrm>
+            <a:off x="1325880" y="5449824"/>
+            <a:ext cx="5120640" cy="310896"/>
+          </a:xfrm>
+          <a:prstGeom prst="rect">
+            <a:avLst/>
+          </a:prstGeom>
+          <a:noFill/>
+          <a:ln/>
+        </p:spPr>
+        <p:txBody>
+          <a:bodyPr wrap="square" lIns="0" tIns="0" rIns="0" bIns="0" rtlCol="0" anchor="t"/>
+          <a:lstStyle/>
+          <a:p>
+            <a:pPr indent="0" marL="0">
+              <a:buNone/>
+            </a:pPr>
+            <a:r>
+              <a:rPr lang="en-US" sz="1400" u="sng" dirty="0">
+                <a:solidFill>
+                  <a:schemeClr val="accent6"/>
+                </a:solidFill>
+                <a:hlinkClick r:id="rId5" invalidUrl="" action="" tgtFrame="" tooltip="" history="1" highlightClick="0" endSnd="0">
+                  <a:extLst>
+                    <a:ext uri="{A12FA001-AC4F-418D-AE19-62706E023703}">
+                      <ahyp:hlinkClr xmlns:ahyp="http://schemas.microsoft.com/office/drawing/2018/hyperlinkcolor" val="tx"/>
+                    </a:ext>
+                  </a:extLst>
+                </a:hlinkClick>
+              </a:rPr>
               <a:t>github.com/ch-lukas/salesforce-process-intelligence</a:t>
             </a:r>
             <a:endParaRPr lang="en-US" sz="1400" dirty="0"/>
@@ -4460,7 +4617,7 @@
       </p:sp>
       <p:sp>
         <p:nvSpPr>
-          <p:cNvPr id="23" name="Screenshot frame"/>
+          <p:cNvPr id="28" name="Screenshot frame"/>
           <p:cNvSpPr/>
           <p:nvPr/>
         </p:nvSpPr>
@@ -4485,14 +4642,14 @@
       </p:sp>
       <p:pic>
         <p:nvPicPr>
-          <p:cNvPr id="24" name="Value case screenshot" descr="Value case one-pager on the hosted site">    </p:cNvPr>
+          <p:cNvPr id="29" name="Value case screenshot" descr="Value case one-pager on the hosted site">    </p:cNvPr>
           <p:cNvPicPr>
             <a:picLocks noChangeAspect="1"/>
           </p:cNvPicPr>
           <p:nvPr/>
         </p:nvPicPr>
         <p:blipFill>
-          <a:blip r:embed="rId5"/>
+          <a:blip r:embed="rId6"/>
           <a:stretch>
             <a:fillRect/>
           </a:stretch>

</xml_diff>

<commit_message>
Apply review feedback: illustrative framing, overlaps, neutral naming
- Headline labelled illustrative and gross, with a visible simulated-data note
- Diagnose framed as associations with cohort sizes; real overlap counts
  replace the priority grid with a pre-commitment checklist
- Value chain reconciled to unrounded inputs (~$667k), tracking defined,
  'New business' filter removed, 'happy path' renamed to winning trace
- Next steps gate the pilot on validated causes, with owners and timing
- Tech slide shows one readable query and an object-to-event mapping
- Site and decks no longer name Salesforce or Apromore as the product;
  site renamed Lead-to-Close Process Intelligence
- Talk track rewritten with tough questions

Co-Authored-By: Claude Opus 5.5 <noreply@anthropic.com>
</commit_message>
<xml_diff>
--- a/deck/salesforce-process-intelligence-tech-setup.pptx
+++ b/deck/salesforce-process-intelligence-tech-setup.pptx
@@ -109,7 +109,7 @@
   <p:extLst>
     <p:ext uri="{521415D9-36F7-43E2-AB2F-B90AF26B5E84}">
       <p14:sectionLst xmlns:p14="http://schemas.microsoft.com/office/powerpoint/2010/main">
-        <p14:section name="Tech setup" id="{535c22b5-914e-55bb-2a51-95b7c26de441}">
+        <p14:section name="Tech setup" id="{a3890b9e-df38-acaf-47f4-752a83dfc439}">
           <p14:sldIdLst>
             <p14:sldId id="256"/>
             <p14:sldId id="257"/>
@@ -608,7 +608,7 @@
           <a:p>
             <a:r>
               <a:rPr lang="en-US" dirty="0"/>
-              <a:t>Left: the trial org standing in for a client's CRM, seeded by seed.py so there's real OpportunityHistory to read. Right: the exact SOQL the extractor runs. Opportunity is the case; leads join via ConvertedOpportunityId and tasks via WhatId. Trial orgs can't backdate history, so the 10-month dataset is simulated in the same object shape.</a:t>
+              <a:t>Left: the trial org standing in for a client's CRM, seeded by seed.py so there's real OpportunityHistory to read. Right: the stage-history query and how each object maps to events; Opportunity Id is the case. Known limits: Task created → completed can include queueing time; open tasks have no completion time and show as zero duration; history can't be backdated in a trial org, so the 10-month dataset is simulated in the same shape. The export produces CSV and XES; an import into a process mining tool is the next step to verify. Production work would add incremental refresh, stable event IDs and reconciliation.</a:t>
             </a:r>
             <a:endParaRPr lang="en-US" dirty="0"/>
           </a:p>
@@ -1861,7 +1861,7 @@
                   <a:schemeClr val="tx2"/>
                 </a:solidFill>
               </a:rPr>
-              <a:t>seed.py loaded 40 [Demo] deals through real stage changes to simulate a client's CRM.</a:t>
+              <a:t>seed.py loaded 40 [Demo] accounts and opportunities to simulate a client's CRM.</a:t>
             </a:r>
             <a:endParaRPr lang="en-US" sz="1400" dirty="0"/>
           </a:p>
@@ -1876,11 +1876,11 @@
         <p:spPr>
           <a:xfrm>
             <a:off x="5897880" y="1280160"/>
-            <a:ext cx="5715000" cy="4297680"/>
+            <a:ext cx="5715000" cy="2057400"/>
           </a:xfrm>
           <a:prstGeom prst="roundRect">
             <a:avLst>
-              <a:gd name="adj" fmla="val 2553"/>
+              <a:gd name="adj" fmla="val 5333"/>
             </a:avLst>
           </a:prstGeom>
           <a:solidFill>
@@ -1958,7 +1958,7 @@
         <p:spPr>
           <a:xfrm>
             <a:off x="6675120" y="1353312"/>
-            <a:ext cx="2743200" cy="237744"/>
+            <a:ext cx="3108960" cy="237744"/>
           </a:xfrm>
           <a:prstGeom prst="rect">
             <a:avLst/>
@@ -1979,7 +1979,7 @@
                   <a:schemeClr val="accent3"/>
                 </a:solidFill>
               </a:rPr>
-              <a:t>pipeline/extract.py</a:t>
+              <a:t>pipeline/extract.py · stage history</a:t>
             </a:r>
             <a:endParaRPr lang="en-US" sz="1100" dirty="0"/>
           </a:p>
@@ -1993,8 +1993,8 @@
         </p:nvSpPr>
         <p:spPr>
           <a:xfrm>
-            <a:off x="6080760" y="1664208"/>
-            <a:ext cx="5440680" cy="3840480"/>
+            <a:off x="6126480" y="1737360"/>
+            <a:ext cx="5349240" cy="1463040"/>
           </a:xfrm>
           <a:prstGeom prst="rect">
             <a:avLst/>
@@ -2008,103 +2008,12 @@
           <a:p>
             <a:pPr indent="0" marL="0">
               <a:lnSpc>
-                <a:spcPct val="100000"/>
+                <a:spcPct val="110000"/>
               </a:lnSpc>
               <a:buNone/>
             </a:pPr>
             <a:r>
-              <a:rPr lang="en-US" sz="1000" dirty="0">
-                <a:solidFill>
-                  <a:srgbClr val="CFE9FE"/>
-                </a:solidFill>
-                <a:latin typeface="Courier New" pitchFamily="34" charset="0"/>
-                <a:ea typeface="Courier New" pitchFamily="34" charset="-122"/>
-                <a:cs typeface="Courier New" pitchFamily="34" charset="-120"/>
-              </a:rPr>
-              <a:t>QUERIES = {</a:t>
-            </a:r>
-            <a:endParaRPr lang="en-US" sz="1000" dirty="0"/>
-          </a:p>
-          <a:p>
-            <a:pPr indent="0" marL="0">
-              <a:lnSpc>
-                <a:spcPct val="100000"/>
-              </a:lnSpc>
-              <a:buNone/>
-            </a:pPr>
-            <a:r>
-              <a:rPr lang="en-US" sz="1000" dirty="0">
-                <a:solidFill>
-                  <a:srgbClr val="CFE9FE"/>
-                </a:solidFill>
-                <a:latin typeface="Courier New" pitchFamily="34" charset="0"/>
-                <a:ea typeface="Courier New" pitchFamily="34" charset="-122"/>
-                <a:cs typeface="Courier New" pitchFamily="34" charset="-120"/>
-              </a:rPr>
-              <a:t>    </a:t>
-            </a:r>
-            <a:pPr indent="0" marL="0">
-              <a:lnSpc>
-                <a:spcPct val="100000"/>
-              </a:lnSpc>
-              <a:buNone/>
-            </a:pPr>
-            <a:r>
-              <a:rPr lang="en-US" sz="1000" dirty="0">
-                <a:solidFill>
-                  <a:srgbClr val="FE9339"/>
-                </a:solidFill>
-                <a:latin typeface="Courier New" pitchFamily="34" charset="0"/>
-                <a:ea typeface="Courier New" pitchFamily="34" charset="-122"/>
-                <a:cs typeface="Courier New" pitchFamily="34" charset="-120"/>
-              </a:rPr>
-              <a:t>"opportunities"</a:t>
-            </a:r>
-            <a:pPr indent="0" marL="0">
-              <a:lnSpc>
-                <a:spcPct val="100000"/>
-              </a:lnSpc>
-              <a:buNone/>
-            </a:pPr>
-            <a:r>
-              <a:rPr lang="en-US" sz="1000" dirty="0">
-                <a:solidFill>
-                  <a:srgbClr val="CFE9FE"/>
-                </a:solidFill>
-                <a:latin typeface="Courier New" pitchFamily="34" charset="0"/>
-                <a:ea typeface="Courier New" pitchFamily="34" charset="-122"/>
-                <a:cs typeface="Courier New" pitchFamily="34" charset="-120"/>
-              </a:rPr>
-              <a:t>: """</a:t>
-            </a:r>
-            <a:endParaRPr lang="en-US" sz="1000" dirty="0"/>
-          </a:p>
-          <a:p>
-            <a:pPr indent="0" marL="0">
-              <a:lnSpc>
-                <a:spcPct val="100000"/>
-              </a:lnSpc>
-              <a:buNone/>
-            </a:pPr>
-            <a:r>
-              <a:rPr lang="en-US" sz="1000" dirty="0">
-                <a:solidFill>
-                  <a:srgbClr val="CFE9FE"/>
-                </a:solidFill>
-                <a:latin typeface="Courier New" pitchFamily="34" charset="0"/>
-                <a:ea typeface="Courier New" pitchFamily="34" charset="-122"/>
-                <a:cs typeface="Courier New" pitchFamily="34" charset="-120"/>
-              </a:rPr>
-              <a:t>    </a:t>
-            </a:r>
-            <a:pPr indent="0" marL="0">
-              <a:lnSpc>
-                <a:spcPct val="100000"/>
-              </a:lnSpc>
-              <a:buNone/>
-            </a:pPr>
-            <a:r>
-              <a:rPr lang="en-US" sz="1000" b="1" dirty="0">
+              <a:rPr lang="en-US" sz="1400" b="1" dirty="0">
                 <a:solidFill>
                   <a:srgbClr val="0B9DE0"/>
                 </a:solidFill>
@@ -2116,12 +2025,12 @@
             </a:r>
             <a:pPr indent="0" marL="0">
               <a:lnSpc>
-                <a:spcPct val="100000"/>
+                <a:spcPct val="110000"/>
               </a:lnSpc>
               <a:buNone/>
             </a:pPr>
             <a:r>
-              <a:rPr lang="en-US" sz="1000" dirty="0">
+              <a:rPr lang="en-US" sz="1400" dirty="0">
                 <a:solidFill>
                   <a:srgbClr val="CFE9FE"/>
                 </a:solidFill>
@@ -2129,19 +2038,19 @@
                 <a:ea typeface="Courier New" pitchFamily="34" charset="-122"/>
                 <a:cs typeface="Courier New" pitchFamily="34" charset="-120"/>
               </a:rPr>
-              <a:t> Id, Name, Amount, StageName, IsWon, IsClosed,</a:t>
-            </a:r>
-            <a:endParaRPr lang="en-US" sz="1000" dirty="0"/>
+              <a:t> OpportunityId, StageName, CreatedDate,</a:t>
+            </a:r>
+            <a:endParaRPr lang="en-US" sz="1400" dirty="0"/>
           </a:p>
           <a:p>
             <a:pPr indent="0" marL="0">
               <a:lnSpc>
-                <a:spcPct val="100000"/>
+                <a:spcPct val="110000"/>
               </a:lnSpc>
               <a:buNone/>
             </a:pPr>
             <a:r>
-              <a:rPr lang="en-US" sz="1000" dirty="0">
+              <a:rPr lang="en-US" sz="1400" dirty="0">
                 <a:solidFill>
                   <a:srgbClr val="CFE9FE"/>
                 </a:solidFill>
@@ -2149,56 +2058,19 @@
                 <a:ea typeface="Courier New" pitchFamily="34" charset="-122"/>
                 <a:cs typeface="Courier New" pitchFamily="34" charset="-120"/>
               </a:rPr>
-              <a:t>           LeadSource, CreatedDate, CloseDate, OwnerId, Owner.Name,</a:t>
-            </a:r>
-            <a:endParaRPr lang="en-US" sz="1000" dirty="0"/>
+              <a:t>       CreatedById, CreatedBy.Name</a:t>
+            </a:r>
+            <a:endParaRPr lang="en-US" sz="1400" dirty="0"/>
           </a:p>
           <a:p>
             <a:pPr indent="0" marL="0">
               <a:lnSpc>
-                <a:spcPct val="100000"/>
+                <a:spcPct val="110000"/>
               </a:lnSpc>
               <a:buNone/>
             </a:pPr>
             <a:r>
-              <a:rPr lang="en-US" sz="1000" dirty="0">
-                <a:solidFill>
-                  <a:srgbClr val="CFE9FE"/>
-                </a:solidFill>
-                <a:latin typeface="Courier New" pitchFamily="34" charset="0"/>
-                <a:ea typeface="Courier New" pitchFamily="34" charset="-122"/>
-                <a:cs typeface="Courier New" pitchFamily="34" charset="-120"/>
-              </a:rPr>
-              <a:t>           Account.Industry, Account.BillingCountry</a:t>
-            </a:r>
-            <a:endParaRPr lang="en-US" sz="1000" dirty="0"/>
-          </a:p>
-          <a:p>
-            <a:pPr indent="0" marL="0">
-              <a:lnSpc>
-                <a:spcPct val="100000"/>
-              </a:lnSpc>
-              <a:buNone/>
-            </a:pPr>
-            <a:r>
-              <a:rPr lang="en-US" sz="1000" dirty="0">
-                <a:solidFill>
-                  <a:srgbClr val="CFE9FE"/>
-                </a:solidFill>
-                <a:latin typeface="Courier New" pitchFamily="34" charset="0"/>
-                <a:ea typeface="Courier New" pitchFamily="34" charset="-122"/>
-                <a:cs typeface="Courier New" pitchFamily="34" charset="-120"/>
-              </a:rPr>
-              <a:t>    </a:t>
-            </a:r>
-            <a:pPr indent="0" marL="0">
-              <a:lnSpc>
-                <a:spcPct val="100000"/>
-              </a:lnSpc>
-              <a:buNone/>
-            </a:pPr>
-            <a:r>
-              <a:rPr lang="en-US" sz="1000" b="1" dirty="0">
+              <a:rPr lang="en-US" sz="1400" b="1" dirty="0">
                 <a:solidFill>
                   <a:srgbClr val="0B9DE0"/>
                 </a:solidFill>
@@ -2210,194 +2082,12 @@
             </a:r>
             <a:pPr indent="0" marL="0">
               <a:lnSpc>
-                <a:spcPct val="100000"/>
+                <a:spcPct val="110000"/>
               </a:lnSpc>
               <a:buNone/>
             </a:pPr>
             <a:r>
-              <a:rPr lang="en-US" sz="1000" dirty="0">
-                <a:solidFill>
-                  <a:srgbClr val="CFE9FE"/>
-                </a:solidFill>
-                <a:latin typeface="Courier New" pitchFamily="34" charset="0"/>
-                <a:ea typeface="Courier New" pitchFamily="34" charset="-122"/>
-                <a:cs typeface="Courier New" pitchFamily="34" charset="-120"/>
-              </a:rPr>
-              <a:t> Opportunity""",</a:t>
-            </a:r>
-            <a:endParaRPr lang="en-US" sz="1000" dirty="0"/>
-          </a:p>
-          <a:p>
-            <a:pPr indent="0" marL="0">
-              <a:lnSpc>
-                <a:spcPct val="100000"/>
-              </a:lnSpc>
-              <a:buNone/>
-            </a:pPr>
-            <a:r>
-              <a:rPr lang="en-US" sz="1000" dirty="0">
-                <a:solidFill>
-                  <a:srgbClr val="CFE9FE"/>
-                </a:solidFill>
-                <a:latin typeface="Courier New" pitchFamily="34" charset="0"/>
-                <a:ea typeface="Courier New" pitchFamily="34" charset="-122"/>
-                <a:cs typeface="Courier New" pitchFamily="34" charset="-120"/>
-              </a:rPr>
-              <a:t>    </a:t>
-            </a:r>
-            <a:pPr indent="0" marL="0">
-              <a:lnSpc>
-                <a:spcPct val="100000"/>
-              </a:lnSpc>
-              <a:buNone/>
-            </a:pPr>
-            <a:r>
-              <a:rPr lang="en-US" sz="1000" dirty="0">
-                <a:solidFill>
-                  <a:srgbClr val="FE9339"/>
-                </a:solidFill>
-                <a:latin typeface="Courier New" pitchFamily="34" charset="0"/>
-                <a:ea typeface="Courier New" pitchFamily="34" charset="-122"/>
-                <a:cs typeface="Courier New" pitchFamily="34" charset="-120"/>
-              </a:rPr>
-              <a:t>"stage_history"</a:t>
-            </a:r>
-            <a:pPr indent="0" marL="0">
-              <a:lnSpc>
-                <a:spcPct val="100000"/>
-              </a:lnSpc>
-              <a:buNone/>
-            </a:pPr>
-            <a:r>
-              <a:rPr lang="en-US" sz="1000" dirty="0">
-                <a:solidFill>
-                  <a:srgbClr val="CFE9FE"/>
-                </a:solidFill>
-                <a:latin typeface="Courier New" pitchFamily="34" charset="0"/>
-                <a:ea typeface="Courier New" pitchFamily="34" charset="-122"/>
-                <a:cs typeface="Courier New" pitchFamily="34" charset="-120"/>
-              </a:rPr>
-              <a:t>: """</a:t>
-            </a:r>
-            <a:endParaRPr lang="en-US" sz="1000" dirty="0"/>
-          </a:p>
-          <a:p>
-            <a:pPr indent="0" marL="0">
-              <a:lnSpc>
-                <a:spcPct val="100000"/>
-              </a:lnSpc>
-              <a:buNone/>
-            </a:pPr>
-            <a:r>
-              <a:rPr lang="en-US" sz="1000" dirty="0">
-                <a:solidFill>
-                  <a:srgbClr val="CFE9FE"/>
-                </a:solidFill>
-                <a:latin typeface="Courier New" pitchFamily="34" charset="0"/>
-                <a:ea typeface="Courier New" pitchFamily="34" charset="-122"/>
-                <a:cs typeface="Courier New" pitchFamily="34" charset="-120"/>
-              </a:rPr>
-              <a:t>    </a:t>
-            </a:r>
-            <a:pPr indent="0" marL="0">
-              <a:lnSpc>
-                <a:spcPct val="100000"/>
-              </a:lnSpc>
-              <a:buNone/>
-            </a:pPr>
-            <a:r>
-              <a:rPr lang="en-US" sz="1000" b="1" dirty="0">
-                <a:solidFill>
-                  <a:srgbClr val="0B9DE0"/>
-                </a:solidFill>
-                <a:latin typeface="Courier New" pitchFamily="34" charset="0"/>
-                <a:ea typeface="Courier New" pitchFamily="34" charset="-122"/>
-                <a:cs typeface="Courier New" pitchFamily="34" charset="-120"/>
-              </a:rPr>
-              <a:t>SELECT</a:t>
-            </a:r>
-            <a:pPr indent="0" marL="0">
-              <a:lnSpc>
-                <a:spcPct val="100000"/>
-              </a:lnSpc>
-              <a:buNone/>
-            </a:pPr>
-            <a:r>
-              <a:rPr lang="en-US" sz="1000" dirty="0">
-                <a:solidFill>
-                  <a:srgbClr val="CFE9FE"/>
-                </a:solidFill>
-                <a:latin typeface="Courier New" pitchFamily="34" charset="0"/>
-                <a:ea typeface="Courier New" pitchFamily="34" charset="-122"/>
-                <a:cs typeface="Courier New" pitchFamily="34" charset="-120"/>
-              </a:rPr>
-              <a:t> OpportunityId, StageName, CreatedDate,</a:t>
-            </a:r>
-            <a:endParaRPr lang="en-US" sz="1000" dirty="0"/>
-          </a:p>
-          <a:p>
-            <a:pPr indent="0" marL="0">
-              <a:lnSpc>
-                <a:spcPct val="100000"/>
-              </a:lnSpc>
-              <a:buNone/>
-            </a:pPr>
-            <a:r>
-              <a:rPr lang="en-US" sz="1000" dirty="0">
-                <a:solidFill>
-                  <a:srgbClr val="CFE9FE"/>
-                </a:solidFill>
-                <a:latin typeface="Courier New" pitchFamily="34" charset="0"/>
-                <a:ea typeface="Courier New" pitchFamily="34" charset="-122"/>
-                <a:cs typeface="Courier New" pitchFamily="34" charset="-120"/>
-              </a:rPr>
-              <a:t>           CreatedById, CreatedBy.Name</a:t>
-            </a:r>
-            <a:endParaRPr lang="en-US" sz="1000" dirty="0"/>
-          </a:p>
-          <a:p>
-            <a:pPr indent="0" marL="0">
-              <a:lnSpc>
-                <a:spcPct val="100000"/>
-              </a:lnSpc>
-              <a:buNone/>
-            </a:pPr>
-            <a:r>
-              <a:rPr lang="en-US" sz="1000" dirty="0">
-                <a:solidFill>
-                  <a:srgbClr val="CFE9FE"/>
-                </a:solidFill>
-                <a:latin typeface="Courier New" pitchFamily="34" charset="0"/>
-                <a:ea typeface="Courier New" pitchFamily="34" charset="-122"/>
-                <a:cs typeface="Courier New" pitchFamily="34" charset="-120"/>
-              </a:rPr>
-              <a:t>    </a:t>
-            </a:r>
-            <a:pPr indent="0" marL="0">
-              <a:lnSpc>
-                <a:spcPct val="100000"/>
-              </a:lnSpc>
-              <a:buNone/>
-            </a:pPr>
-            <a:r>
-              <a:rPr lang="en-US" sz="1000" b="1" dirty="0">
-                <a:solidFill>
-                  <a:srgbClr val="0B9DE0"/>
-                </a:solidFill>
-                <a:latin typeface="Courier New" pitchFamily="34" charset="0"/>
-                <a:ea typeface="Courier New" pitchFamily="34" charset="-122"/>
-                <a:cs typeface="Courier New" pitchFamily="34" charset="-120"/>
-              </a:rPr>
-              <a:t>FROM</a:t>
-            </a:r>
-            <a:pPr indent="0" marL="0">
-              <a:lnSpc>
-                <a:spcPct val="100000"/>
-              </a:lnSpc>
-              <a:buNone/>
-            </a:pPr>
-            <a:r>
-              <a:rPr lang="en-US" sz="1000" dirty="0">
+              <a:rPr lang="en-US" sz="1400" dirty="0">
                 <a:solidFill>
                   <a:srgbClr val="CFE9FE"/>
                 </a:solidFill>
@@ -2407,34 +2097,17 @@
               </a:rPr>
               <a:t> OpportunityHistory</a:t>
             </a:r>
-            <a:endParaRPr lang="en-US" sz="1000" dirty="0"/>
+            <a:endParaRPr lang="en-US" sz="1400" dirty="0"/>
           </a:p>
           <a:p>
             <a:pPr indent="0" marL="0">
               <a:lnSpc>
-                <a:spcPct val="100000"/>
+                <a:spcPct val="110000"/>
               </a:lnSpc>
               <a:buNone/>
             </a:pPr>
             <a:r>
-              <a:rPr lang="en-US" sz="1000" dirty="0">
-                <a:solidFill>
-                  <a:srgbClr val="CFE9FE"/>
-                </a:solidFill>
-                <a:latin typeface="Courier New" pitchFamily="34" charset="0"/>
-                <a:ea typeface="Courier New" pitchFamily="34" charset="-122"/>
-                <a:cs typeface="Courier New" pitchFamily="34" charset="-120"/>
-              </a:rPr>
-              <a:t>    </a:t>
-            </a:r>
-            <a:pPr indent="0" marL="0">
-              <a:lnSpc>
-                <a:spcPct val="100000"/>
-              </a:lnSpc>
-              <a:buNone/>
-            </a:pPr>
-            <a:r>
-              <a:rPr lang="en-US" sz="1000" b="1" dirty="0">
+              <a:rPr lang="en-US" sz="1400" b="1" dirty="0">
                 <a:solidFill>
                   <a:srgbClr val="0B9DE0"/>
                 </a:solidFill>
@@ -2446,12 +2119,12 @@
             </a:r>
             <a:pPr indent="0" marL="0">
               <a:lnSpc>
-                <a:spcPct val="100000"/>
+                <a:spcPct val="110000"/>
               </a:lnSpc>
               <a:buNone/>
             </a:pPr>
             <a:r>
-              <a:rPr lang="en-US" sz="1000" dirty="0">
+              <a:rPr lang="en-US" sz="1400" dirty="0">
                 <a:solidFill>
                   <a:srgbClr val="CFE9FE"/>
                 </a:solidFill>
@@ -2459,595 +2132,665 @@
                 <a:ea typeface="Courier New" pitchFamily="34" charset="-122"/>
                 <a:cs typeface="Courier New" pitchFamily="34" charset="-120"/>
               </a:rPr>
-              <a:t> OpportunityId, CreatedDate""",</a:t>
-            </a:r>
-            <a:endParaRPr lang="en-US" sz="1000" dirty="0"/>
-          </a:p>
-          <a:p>
-            <a:pPr indent="0" marL="0">
-              <a:lnSpc>
-                <a:spcPct val="100000"/>
-              </a:lnSpc>
-              <a:buNone/>
-            </a:pPr>
-            <a:r>
-              <a:rPr lang="en-US" sz="1000" dirty="0">
-                <a:solidFill>
-                  <a:srgbClr val="CFE9FE"/>
-                </a:solidFill>
-                <a:latin typeface="Courier New" pitchFamily="34" charset="0"/>
-                <a:ea typeface="Courier New" pitchFamily="34" charset="-122"/>
-                <a:cs typeface="Courier New" pitchFamily="34" charset="-120"/>
-              </a:rPr>
-              <a:t>    </a:t>
-            </a:r>
-            <a:pPr indent="0" marL="0">
-              <a:lnSpc>
-                <a:spcPct val="100000"/>
-              </a:lnSpc>
-              <a:buNone/>
-            </a:pPr>
-            <a:r>
-              <a:rPr lang="en-US" sz="1000" dirty="0">
-                <a:solidFill>
-                  <a:srgbClr val="FE9339"/>
-                </a:solidFill>
-                <a:latin typeface="Courier New" pitchFamily="34" charset="0"/>
-                <a:ea typeface="Courier New" pitchFamily="34" charset="-122"/>
-                <a:cs typeface="Courier New" pitchFamily="34" charset="-120"/>
-              </a:rPr>
-              <a:t>"tasks"</a:t>
-            </a:r>
-            <a:pPr indent="0" marL="0">
-              <a:lnSpc>
-                <a:spcPct val="100000"/>
-              </a:lnSpc>
-              <a:buNone/>
-            </a:pPr>
-            <a:r>
-              <a:rPr lang="en-US" sz="1000" dirty="0">
-                <a:solidFill>
-                  <a:srgbClr val="CFE9FE"/>
-                </a:solidFill>
-                <a:latin typeface="Courier New" pitchFamily="34" charset="0"/>
-                <a:ea typeface="Courier New" pitchFamily="34" charset="-122"/>
-                <a:cs typeface="Courier New" pitchFamily="34" charset="-120"/>
-              </a:rPr>
-              <a:t>: """</a:t>
-            </a:r>
-            <a:endParaRPr lang="en-US" sz="1000" dirty="0"/>
-          </a:p>
-          <a:p>
-            <a:pPr indent="0" marL="0">
-              <a:lnSpc>
-                <a:spcPct val="100000"/>
-              </a:lnSpc>
-              <a:buNone/>
-            </a:pPr>
-            <a:r>
-              <a:rPr lang="en-US" sz="1000" dirty="0">
-                <a:solidFill>
-                  <a:srgbClr val="CFE9FE"/>
-                </a:solidFill>
-                <a:latin typeface="Courier New" pitchFamily="34" charset="0"/>
-                <a:ea typeface="Courier New" pitchFamily="34" charset="-122"/>
-                <a:cs typeface="Courier New" pitchFamily="34" charset="-120"/>
-              </a:rPr>
-              <a:t>    </a:t>
-            </a:r>
-            <a:pPr indent="0" marL="0">
-              <a:lnSpc>
-                <a:spcPct val="100000"/>
-              </a:lnSpc>
-              <a:buNone/>
-            </a:pPr>
-            <a:r>
-              <a:rPr lang="en-US" sz="1000" b="1" dirty="0">
-                <a:solidFill>
-                  <a:srgbClr val="0B9DE0"/>
-                </a:solidFill>
-                <a:latin typeface="Courier New" pitchFamily="34" charset="0"/>
-                <a:ea typeface="Courier New" pitchFamily="34" charset="-122"/>
-                <a:cs typeface="Courier New" pitchFamily="34" charset="-120"/>
-              </a:rPr>
-              <a:t>SELECT</a:t>
-            </a:r>
-            <a:pPr indent="0" marL="0">
-              <a:lnSpc>
-                <a:spcPct val="100000"/>
-              </a:lnSpc>
-              <a:buNone/>
-            </a:pPr>
-            <a:r>
-              <a:rPr lang="en-US" sz="1000" dirty="0">
-                <a:solidFill>
-                  <a:srgbClr val="CFE9FE"/>
-                </a:solidFill>
-                <a:latin typeface="Courier New" pitchFamily="34" charset="0"/>
-                <a:ea typeface="Courier New" pitchFamily="34" charset="-122"/>
-                <a:cs typeface="Courier New" pitchFamily="34" charset="-120"/>
-              </a:rPr>
-              <a:t> WhatId, Subject, CreatedDate, CompletedDateTime,</a:t>
-            </a:r>
-            <a:endParaRPr lang="en-US" sz="1000" dirty="0"/>
-          </a:p>
-          <a:p>
-            <a:pPr indent="0" marL="0">
-              <a:lnSpc>
-                <a:spcPct val="100000"/>
-              </a:lnSpc>
-              <a:buNone/>
-            </a:pPr>
-            <a:r>
-              <a:rPr lang="en-US" sz="1000" dirty="0">
-                <a:solidFill>
-                  <a:srgbClr val="CFE9FE"/>
-                </a:solidFill>
-                <a:latin typeface="Courier New" pitchFamily="34" charset="0"/>
-                <a:ea typeface="Courier New" pitchFamily="34" charset="-122"/>
-                <a:cs typeface="Courier New" pitchFamily="34" charset="-120"/>
-              </a:rPr>
-              <a:t>           OwnerId, Owner.Name, Status</a:t>
-            </a:r>
-            <a:endParaRPr lang="en-US" sz="1000" dirty="0"/>
-          </a:p>
-          <a:p>
-            <a:pPr indent="0" marL="0">
-              <a:lnSpc>
-                <a:spcPct val="100000"/>
-              </a:lnSpc>
-              <a:buNone/>
-            </a:pPr>
-            <a:r>
-              <a:rPr lang="en-US" sz="1000" dirty="0">
-                <a:solidFill>
-                  <a:srgbClr val="CFE9FE"/>
-                </a:solidFill>
-                <a:latin typeface="Courier New" pitchFamily="34" charset="0"/>
-                <a:ea typeface="Courier New" pitchFamily="34" charset="-122"/>
-                <a:cs typeface="Courier New" pitchFamily="34" charset="-120"/>
-              </a:rPr>
-              <a:t>    </a:t>
-            </a:r>
-            <a:pPr indent="0" marL="0">
-              <a:lnSpc>
-                <a:spcPct val="100000"/>
-              </a:lnSpc>
-              <a:buNone/>
-            </a:pPr>
-            <a:r>
-              <a:rPr lang="en-US" sz="1000" b="1" dirty="0">
-                <a:solidFill>
-                  <a:srgbClr val="0B9DE0"/>
-                </a:solidFill>
-                <a:latin typeface="Courier New" pitchFamily="34" charset="0"/>
-                <a:ea typeface="Courier New" pitchFamily="34" charset="-122"/>
-                <a:cs typeface="Courier New" pitchFamily="34" charset="-120"/>
-              </a:rPr>
-              <a:t>FROM</a:t>
-            </a:r>
-            <a:pPr indent="0" marL="0">
-              <a:lnSpc>
-                <a:spcPct val="100000"/>
-              </a:lnSpc>
-              <a:buNone/>
-            </a:pPr>
-            <a:r>
-              <a:rPr lang="en-US" sz="1000" dirty="0">
-                <a:solidFill>
-                  <a:srgbClr val="CFE9FE"/>
-                </a:solidFill>
-                <a:latin typeface="Courier New" pitchFamily="34" charset="0"/>
-                <a:ea typeface="Courier New" pitchFamily="34" charset="-122"/>
-                <a:cs typeface="Courier New" pitchFamily="34" charset="-120"/>
-              </a:rPr>
-              <a:t> Task</a:t>
-            </a:r>
-            <a:endParaRPr lang="en-US" sz="1000" dirty="0"/>
-          </a:p>
-          <a:p>
-            <a:pPr indent="0" marL="0">
-              <a:lnSpc>
-                <a:spcPct val="100000"/>
-              </a:lnSpc>
-              <a:buNone/>
-            </a:pPr>
-            <a:r>
-              <a:rPr lang="en-US" sz="1000" dirty="0">
-                <a:solidFill>
-                  <a:srgbClr val="CFE9FE"/>
-                </a:solidFill>
-                <a:latin typeface="Courier New" pitchFamily="34" charset="0"/>
-                <a:ea typeface="Courier New" pitchFamily="34" charset="-122"/>
-                <a:cs typeface="Courier New" pitchFamily="34" charset="-120"/>
-              </a:rPr>
-              <a:t>    </a:t>
-            </a:r>
-            <a:pPr indent="0" marL="0">
-              <a:lnSpc>
-                <a:spcPct val="100000"/>
-              </a:lnSpc>
-              <a:buNone/>
-            </a:pPr>
-            <a:r>
-              <a:rPr lang="en-US" sz="1000" b="1" dirty="0">
-                <a:solidFill>
-                  <a:srgbClr val="0B9DE0"/>
-                </a:solidFill>
-                <a:latin typeface="Courier New" pitchFamily="34" charset="0"/>
-                <a:ea typeface="Courier New" pitchFamily="34" charset="-122"/>
-                <a:cs typeface="Courier New" pitchFamily="34" charset="-120"/>
-              </a:rPr>
-              <a:t>WHERE</a:t>
-            </a:r>
-            <a:pPr indent="0" marL="0">
-              <a:lnSpc>
-                <a:spcPct val="100000"/>
-              </a:lnSpc>
-              <a:buNone/>
-            </a:pPr>
-            <a:r>
-              <a:rPr lang="en-US" sz="1000" dirty="0">
-                <a:solidFill>
-                  <a:srgbClr val="CFE9FE"/>
-                </a:solidFill>
-                <a:latin typeface="Courier New" pitchFamily="34" charset="0"/>
-                <a:ea typeface="Courier New" pitchFamily="34" charset="-122"/>
-                <a:cs typeface="Courier New" pitchFamily="34" charset="-120"/>
-              </a:rPr>
-              <a:t> What.Type = </a:t>
-            </a:r>
-            <a:pPr indent="0" marL="0">
-              <a:lnSpc>
-                <a:spcPct val="100000"/>
-              </a:lnSpc>
-              <a:buNone/>
-            </a:pPr>
-            <a:r>
-              <a:rPr lang="en-US" sz="1000" dirty="0">
-                <a:solidFill>
-                  <a:srgbClr val="FE9339"/>
-                </a:solidFill>
-                <a:latin typeface="Courier New" pitchFamily="34" charset="0"/>
-                <a:ea typeface="Courier New" pitchFamily="34" charset="-122"/>
-                <a:cs typeface="Courier New" pitchFamily="34" charset="-120"/>
-              </a:rPr>
-              <a:t>'Opportunity'</a:t>
-            </a:r>
-            <a:pPr indent="0" marL="0">
-              <a:lnSpc>
-                <a:spcPct val="100000"/>
-              </a:lnSpc>
-              <a:buNone/>
-            </a:pPr>
-            <a:r>
-              <a:rPr lang="en-US" sz="1000" dirty="0">
-                <a:solidFill>
-                  <a:srgbClr val="FE9339"/>
-                </a:solidFill>
-                <a:latin typeface="Courier New" pitchFamily="34" charset="0"/>
-                <a:ea typeface="Courier New" pitchFamily="34" charset="-122"/>
-                <a:cs typeface="Courier New" pitchFamily="34" charset="-120"/>
-              </a:rPr>
-              <a:t>""",</a:t>
-            </a:r>
-            <a:endParaRPr lang="en-US" sz="1000" dirty="0"/>
-          </a:p>
-          <a:p>
-            <a:pPr indent="0" marL="0">
-              <a:lnSpc>
-                <a:spcPct val="100000"/>
-              </a:lnSpc>
-              <a:buNone/>
-            </a:pPr>
-            <a:r>
-              <a:rPr lang="en-US" sz="1000" dirty="0">
-                <a:solidFill>
-                  <a:srgbClr val="CFE9FE"/>
-                </a:solidFill>
-                <a:latin typeface="Courier New" pitchFamily="34" charset="0"/>
-                <a:ea typeface="Courier New" pitchFamily="34" charset="-122"/>
-                <a:cs typeface="Courier New" pitchFamily="34" charset="-120"/>
-              </a:rPr>
-              <a:t>    </a:t>
-            </a:r>
-            <a:pPr indent="0" marL="0">
-              <a:lnSpc>
-                <a:spcPct val="100000"/>
-              </a:lnSpc>
-              <a:buNone/>
-            </a:pPr>
-            <a:r>
-              <a:rPr lang="en-US" sz="1000" dirty="0">
-                <a:solidFill>
-                  <a:srgbClr val="FE9339"/>
-                </a:solidFill>
-                <a:latin typeface="Courier New" pitchFamily="34" charset="0"/>
-                <a:ea typeface="Courier New" pitchFamily="34" charset="-122"/>
-                <a:cs typeface="Courier New" pitchFamily="34" charset="-120"/>
-              </a:rPr>
-              <a:t>"leads"</a:t>
-            </a:r>
-            <a:pPr indent="0" marL="0">
-              <a:lnSpc>
-                <a:spcPct val="100000"/>
-              </a:lnSpc>
-              <a:buNone/>
-            </a:pPr>
-            <a:r>
-              <a:rPr lang="en-US" sz="1000" dirty="0">
-                <a:solidFill>
-                  <a:srgbClr val="CFE9FE"/>
-                </a:solidFill>
-                <a:latin typeface="Courier New" pitchFamily="34" charset="0"/>
-                <a:ea typeface="Courier New" pitchFamily="34" charset="-122"/>
-                <a:cs typeface="Courier New" pitchFamily="34" charset="-120"/>
-              </a:rPr>
-              <a:t>: """</a:t>
-            </a:r>
-            <a:endParaRPr lang="en-US" sz="1000" dirty="0"/>
-          </a:p>
-          <a:p>
-            <a:pPr indent="0" marL="0">
-              <a:lnSpc>
-                <a:spcPct val="100000"/>
-              </a:lnSpc>
-              <a:buNone/>
-            </a:pPr>
-            <a:r>
-              <a:rPr lang="en-US" sz="1000" dirty="0">
-                <a:solidFill>
-                  <a:srgbClr val="CFE9FE"/>
-                </a:solidFill>
-                <a:latin typeface="Courier New" pitchFamily="34" charset="0"/>
-                <a:ea typeface="Courier New" pitchFamily="34" charset="-122"/>
-                <a:cs typeface="Courier New" pitchFamily="34" charset="-120"/>
-              </a:rPr>
-              <a:t>    </a:t>
-            </a:r>
-            <a:pPr indent="0" marL="0">
-              <a:lnSpc>
-                <a:spcPct val="100000"/>
-              </a:lnSpc>
-              <a:buNone/>
-            </a:pPr>
-            <a:r>
-              <a:rPr lang="en-US" sz="1000" b="1" dirty="0">
-                <a:solidFill>
-                  <a:srgbClr val="0B9DE0"/>
-                </a:solidFill>
-                <a:latin typeface="Courier New" pitchFamily="34" charset="0"/>
-                <a:ea typeface="Courier New" pitchFamily="34" charset="-122"/>
-                <a:cs typeface="Courier New" pitchFamily="34" charset="-120"/>
-              </a:rPr>
-              <a:t>SELECT</a:t>
-            </a:r>
-            <a:pPr indent="0" marL="0">
-              <a:lnSpc>
-                <a:spcPct val="100000"/>
-              </a:lnSpc>
-              <a:buNone/>
-            </a:pPr>
-            <a:r>
-              <a:rPr lang="en-US" sz="1000" dirty="0">
-                <a:solidFill>
-                  <a:srgbClr val="CFE9FE"/>
-                </a:solidFill>
-                <a:latin typeface="Courier New" pitchFamily="34" charset="0"/>
-                <a:ea typeface="Courier New" pitchFamily="34" charset="-122"/>
-                <a:cs typeface="Courier New" pitchFamily="34" charset="-120"/>
-              </a:rPr>
-              <a:t> Id, CreatedDate, ConvertedDate, ConvertedOpportunityId,</a:t>
-            </a:r>
-            <a:endParaRPr lang="en-US" sz="1000" dirty="0"/>
-          </a:p>
-          <a:p>
-            <a:pPr indent="0" marL="0">
-              <a:lnSpc>
-                <a:spcPct val="100000"/>
-              </a:lnSpc>
-              <a:buNone/>
-            </a:pPr>
-            <a:r>
-              <a:rPr lang="en-US" sz="1000" dirty="0">
-                <a:solidFill>
-                  <a:srgbClr val="CFE9FE"/>
-                </a:solidFill>
-                <a:latin typeface="Courier New" pitchFamily="34" charset="0"/>
-                <a:ea typeface="Courier New" pitchFamily="34" charset="-122"/>
-                <a:cs typeface="Courier New" pitchFamily="34" charset="-120"/>
-              </a:rPr>
-              <a:t>           OwnerId, Owner.Name</a:t>
-            </a:r>
-            <a:endParaRPr lang="en-US" sz="1000" dirty="0"/>
-          </a:p>
-          <a:p>
-            <a:pPr indent="0" marL="0">
-              <a:lnSpc>
-                <a:spcPct val="100000"/>
-              </a:lnSpc>
-              <a:buNone/>
-            </a:pPr>
-            <a:r>
-              <a:rPr lang="en-US" sz="1000" dirty="0">
-                <a:solidFill>
-                  <a:srgbClr val="CFE9FE"/>
-                </a:solidFill>
-                <a:latin typeface="Courier New" pitchFamily="34" charset="0"/>
-                <a:ea typeface="Courier New" pitchFamily="34" charset="-122"/>
-                <a:cs typeface="Courier New" pitchFamily="34" charset="-120"/>
-              </a:rPr>
-              <a:t>    </a:t>
-            </a:r>
-            <a:pPr indent="0" marL="0">
-              <a:lnSpc>
-                <a:spcPct val="100000"/>
-              </a:lnSpc>
-              <a:buNone/>
-            </a:pPr>
-            <a:r>
-              <a:rPr lang="en-US" sz="1000" b="1" dirty="0">
-                <a:solidFill>
-                  <a:srgbClr val="0B9DE0"/>
-                </a:solidFill>
-                <a:latin typeface="Courier New" pitchFamily="34" charset="0"/>
-                <a:ea typeface="Courier New" pitchFamily="34" charset="-122"/>
-                <a:cs typeface="Courier New" pitchFamily="34" charset="-120"/>
-              </a:rPr>
-              <a:t>FROM</a:t>
-            </a:r>
-            <a:pPr indent="0" marL="0">
-              <a:lnSpc>
-                <a:spcPct val="100000"/>
-              </a:lnSpc>
-              <a:buNone/>
-            </a:pPr>
-            <a:r>
-              <a:rPr lang="en-US" sz="1000" dirty="0">
-                <a:solidFill>
-                  <a:srgbClr val="CFE9FE"/>
-                </a:solidFill>
-                <a:latin typeface="Courier New" pitchFamily="34" charset="0"/>
-                <a:ea typeface="Courier New" pitchFamily="34" charset="-122"/>
-                <a:cs typeface="Courier New" pitchFamily="34" charset="-120"/>
-              </a:rPr>
-              <a:t> Lead</a:t>
-            </a:r>
-            <a:endParaRPr lang="en-US" sz="1000" dirty="0"/>
-          </a:p>
-          <a:p>
-            <a:pPr indent="0" marL="0">
-              <a:lnSpc>
-                <a:spcPct val="100000"/>
-              </a:lnSpc>
-              <a:buNone/>
-            </a:pPr>
-            <a:r>
-              <a:rPr lang="en-US" sz="1000" dirty="0">
-                <a:solidFill>
-                  <a:srgbClr val="CFE9FE"/>
-                </a:solidFill>
-                <a:latin typeface="Courier New" pitchFamily="34" charset="0"/>
-                <a:ea typeface="Courier New" pitchFamily="34" charset="-122"/>
-                <a:cs typeface="Courier New" pitchFamily="34" charset="-120"/>
-              </a:rPr>
-              <a:t>    </a:t>
-            </a:r>
-            <a:pPr indent="0" marL="0">
-              <a:lnSpc>
-                <a:spcPct val="100000"/>
-              </a:lnSpc>
-              <a:buNone/>
-            </a:pPr>
-            <a:r>
-              <a:rPr lang="en-US" sz="1000" b="1" dirty="0">
-                <a:solidFill>
-                  <a:srgbClr val="0B9DE0"/>
-                </a:solidFill>
-                <a:latin typeface="Courier New" pitchFamily="34" charset="0"/>
-                <a:ea typeface="Courier New" pitchFamily="34" charset="-122"/>
-                <a:cs typeface="Courier New" pitchFamily="34" charset="-120"/>
-              </a:rPr>
-              <a:t>WHERE</a:t>
-            </a:r>
-            <a:pPr indent="0" marL="0">
-              <a:lnSpc>
-                <a:spcPct val="100000"/>
-              </a:lnSpc>
-              <a:buNone/>
-            </a:pPr>
-            <a:r>
-              <a:rPr lang="en-US" sz="1000" dirty="0">
-                <a:solidFill>
-                  <a:srgbClr val="CFE9FE"/>
-                </a:solidFill>
-                <a:latin typeface="Courier New" pitchFamily="34" charset="0"/>
-                <a:ea typeface="Courier New" pitchFamily="34" charset="-122"/>
-                <a:cs typeface="Courier New" pitchFamily="34" charset="-120"/>
-              </a:rPr>
-              <a:t> IsConverted = true</a:t>
-            </a:r>
-            <a:endParaRPr lang="en-US" sz="1000" dirty="0"/>
-          </a:p>
-          <a:p>
-            <a:pPr indent="0" marL="0">
-              <a:lnSpc>
-                <a:spcPct val="100000"/>
-              </a:lnSpc>
-              <a:buNone/>
-            </a:pPr>
-            <a:r>
-              <a:rPr lang="en-US" sz="1000" dirty="0">
-                <a:solidFill>
-                  <a:srgbClr val="CFE9FE"/>
-                </a:solidFill>
-                <a:latin typeface="Courier New" pitchFamily="34" charset="0"/>
-                <a:ea typeface="Courier New" pitchFamily="34" charset="-122"/>
-                <a:cs typeface="Courier New" pitchFamily="34" charset="-120"/>
-              </a:rPr>
-              <a:t>      </a:t>
-            </a:r>
-            <a:pPr indent="0" marL="0">
-              <a:lnSpc>
-                <a:spcPct val="100000"/>
-              </a:lnSpc>
-              <a:buNone/>
-            </a:pPr>
-            <a:r>
-              <a:rPr lang="en-US" sz="1000" b="1" dirty="0">
-                <a:solidFill>
-                  <a:srgbClr val="0B9DE0"/>
-                </a:solidFill>
-                <a:latin typeface="Courier New" pitchFamily="34" charset="0"/>
-                <a:ea typeface="Courier New" pitchFamily="34" charset="-122"/>
-                <a:cs typeface="Courier New" pitchFamily="34" charset="-120"/>
-              </a:rPr>
-              <a:t>AND</a:t>
-            </a:r>
-            <a:pPr indent="0" marL="0">
-              <a:lnSpc>
-                <a:spcPct val="100000"/>
-              </a:lnSpc>
-              <a:buNone/>
-            </a:pPr>
-            <a:r>
-              <a:rPr lang="en-US" sz="1000" dirty="0">
-                <a:solidFill>
-                  <a:srgbClr val="CFE9FE"/>
-                </a:solidFill>
-                <a:latin typeface="Courier New" pitchFamily="34" charset="0"/>
-                <a:ea typeface="Courier New" pitchFamily="34" charset="-122"/>
-                <a:cs typeface="Courier New" pitchFamily="34" charset="-120"/>
-              </a:rPr>
-              <a:t> ConvertedOpportunityId != null""",</a:t>
-            </a:r>
-            <a:endParaRPr lang="en-US" sz="1000" dirty="0"/>
-          </a:p>
-          <a:p>
-            <a:pPr indent="0" marL="0">
-              <a:lnSpc>
-                <a:spcPct val="100000"/>
-              </a:lnSpc>
-              <a:buNone/>
-            </a:pPr>
-            <a:r>
-              <a:rPr lang="en-US" sz="1000" dirty="0">
-                <a:solidFill>
-                  <a:srgbClr val="CFE9FE"/>
-                </a:solidFill>
-                <a:latin typeface="Courier New" pitchFamily="34" charset="0"/>
-                <a:ea typeface="Courier New" pitchFamily="34" charset="-122"/>
-                <a:cs typeface="Courier New" pitchFamily="34" charset="-120"/>
-              </a:rPr>
-              <a:t>}</a:t>
-            </a:r>
-            <a:endParaRPr lang="en-US" sz="1000" dirty="0"/>
-          </a:p>
-        </p:txBody>
-      </p:sp>
-      <p:sp>
-        <p:nvSpPr>
-          <p:cNvPr id="12" name="Code caption"/>
+              <a:t> OpportunityId, CreatedDate</a:t>
+            </a:r>
+            <a:endParaRPr lang="en-US" sz="1400" dirty="0"/>
+          </a:p>
+        </p:txBody>
+      </p:sp>
+      <p:graphicFrame>
+        <p:nvGraphicFramePr>
+          <p:cNvPr id="3" name="Object to event mapping"/>
+          <p:cNvGraphicFramePr>
+            <a:graphicFrameLocks noGrp="1"/>
+          </p:cNvGraphicFramePr>
+          <p:nvPr>
+            <p:extLst>
+              <p:ext uri="{D42A27DB-BD31-4B8C-83A1-F6EECF244321}">
+                <p14:modId xmlns:p14="http://schemas.microsoft.com/office/powerpoint/2010/main" val="1579011935"/>
+              </p:ext>
+            </p:extLst>
+          </p:nvPr>
+        </p:nvGraphicFramePr>
+        <p:xfrm>
+          <a:off x="5897880" y="3520440"/>
+          <a:ext cx="5715000" cy="914400"/>
+        </p:xfrm>
+        <a:graphic>
+          <a:graphicData uri="http://schemas.openxmlformats.org/drawingml/2006/table">
+            <a:tbl>
+              <a:tblPr/>
+              <a:tblGrid>
+                <a:gridCol w="2514600"/>
+                <a:gridCol w="3200400"/>
+              </a:tblGrid>
+              <a:tr h="384048">
+                <a:tc>
+                  <a:txBody>
+                    <a:bodyPr/>
+                    <a:lstStyle/>
+                    <a:p>
+                      <a:pPr indent="0" marL="0">
+                        <a:buNone/>
+                      </a:pPr>
+                      <a:r>
+                        <a:rPr lang="en-US" sz="1300" b="1" dirty="0">
+                          <a:solidFill>
+                            <a:schemeClr val="bg1"/>
+                          </a:solidFill>
+                        </a:rPr>
+                        <a:t>Salesforce object</a:t>
+                      </a:r>
+                      <a:endParaRPr lang="en-US" sz="1300" dirty="0"/>
+                    </a:p>
+                  </a:txBody>
+                  <a:tcPr marL="91440" marR="91440" marT="36576" marB="36576" anchor="ctr">
+                    <a:lnL w="9525" cap="flat" cmpd="sng" algn="ctr">
+                      <a:solidFill>
+                        <a:srgbClr val="CFE9FE"/>
+                      </a:solidFill>
+                      <a:prstDash val="solid"/>
+                      <a:round/>
+                      <a:headEnd type="none" w="med" len="med"/>
+                      <a:tailEnd type="none" w="med" len="med"/>
+                    </a:lnL>
+                    <a:lnR w="9525" cap="flat" cmpd="sng" algn="ctr">
+                      <a:solidFill>
+                        <a:srgbClr val="CFE9FE"/>
+                      </a:solidFill>
+                      <a:prstDash val="solid"/>
+                      <a:round/>
+                      <a:headEnd type="none" w="med" len="med"/>
+                      <a:tailEnd type="none" w="med" len="med"/>
+                    </a:lnR>
+                    <a:lnT w="9525" cap="flat" cmpd="sng" algn="ctr">
+                      <a:solidFill>
+                        <a:srgbClr val="CFE9FE"/>
+                      </a:solidFill>
+                      <a:prstDash val="solid"/>
+                      <a:round/>
+                      <a:headEnd type="none" w="med" len="med"/>
+                      <a:tailEnd type="none" w="med" len="med"/>
+                    </a:lnT>
+                    <a:lnB w="9525" cap="flat" cmpd="sng" algn="ctr">
+                      <a:solidFill>
+                        <a:srgbClr val="CFE9FE"/>
+                      </a:solidFill>
+                      <a:prstDash val="solid"/>
+                      <a:round/>
+                      <a:headEnd type="none" w="med" len="med"/>
+                      <a:tailEnd type="none" w="med" len="med"/>
+                    </a:lnB>
+                    <a:solidFill>
+                      <a:schemeClr val="tx2"/>
+                    </a:solidFill>
+                  </a:tcPr>
+                </a:tc>
+                <a:tc>
+                  <a:txBody>
+                    <a:bodyPr/>
+                    <a:lstStyle/>
+                    <a:p>
+                      <a:pPr indent="0" marL="0">
+                        <a:buNone/>
+                      </a:pPr>
+                      <a:r>
+                        <a:rPr lang="en-US" sz="1300" b="1" dirty="0">
+                          <a:solidFill>
+                            <a:schemeClr val="bg1"/>
+                          </a:solidFill>
+                        </a:rPr>
+                        <a:t>Becomes in the event log</a:t>
+                      </a:r>
+                      <a:endParaRPr lang="en-US" sz="1300" dirty="0"/>
+                    </a:p>
+                  </a:txBody>
+                  <a:tcPr marL="91440" marR="91440" marT="36576" marB="36576" anchor="ctr">
+                    <a:lnL w="9525" cap="flat" cmpd="sng" algn="ctr">
+                      <a:solidFill>
+                        <a:srgbClr val="CFE9FE"/>
+                      </a:solidFill>
+                      <a:prstDash val="solid"/>
+                      <a:round/>
+                      <a:headEnd type="none" w="med" len="med"/>
+                      <a:tailEnd type="none" w="med" len="med"/>
+                    </a:lnL>
+                    <a:lnR w="9525" cap="flat" cmpd="sng" algn="ctr">
+                      <a:solidFill>
+                        <a:srgbClr val="CFE9FE"/>
+                      </a:solidFill>
+                      <a:prstDash val="solid"/>
+                      <a:round/>
+                      <a:headEnd type="none" w="med" len="med"/>
+                      <a:tailEnd type="none" w="med" len="med"/>
+                    </a:lnR>
+                    <a:lnT w="9525" cap="flat" cmpd="sng" algn="ctr">
+                      <a:solidFill>
+                        <a:srgbClr val="CFE9FE"/>
+                      </a:solidFill>
+                      <a:prstDash val="solid"/>
+                      <a:round/>
+                      <a:headEnd type="none" w="med" len="med"/>
+                      <a:tailEnd type="none" w="med" len="med"/>
+                    </a:lnT>
+                    <a:lnB w="9525" cap="flat" cmpd="sng" algn="ctr">
+                      <a:solidFill>
+                        <a:srgbClr val="CFE9FE"/>
+                      </a:solidFill>
+                      <a:prstDash val="solid"/>
+                      <a:round/>
+                      <a:headEnd type="none" w="med" len="med"/>
+                      <a:tailEnd type="none" w="med" len="med"/>
+                    </a:lnB>
+                    <a:solidFill>
+                      <a:schemeClr val="tx2"/>
+                    </a:solidFill>
+                  </a:tcPr>
+                </a:tc>
+              </a:tr>
+              <a:tr h="384048">
+                <a:tc>
+                  <a:txBody>
+                    <a:bodyPr/>
+                    <a:lstStyle/>
+                    <a:p>
+                      <a:pPr indent="0" marL="0">
+                        <a:buNone/>
+                      </a:pPr>
+                      <a:r>
+                        <a:rPr lang="en-US" sz="1300" dirty="0">
+                          <a:solidFill>
+                            <a:schemeClr val="tx1"/>
+                          </a:solidFill>
+                        </a:rPr>
+                        <a:t>Opportunity</a:t>
+                      </a:r>
+                      <a:endParaRPr lang="en-US" sz="1300" dirty="0"/>
+                    </a:p>
+                  </a:txBody>
+                  <a:tcPr marL="91440" marR="91440" marT="36576" marB="36576" anchor="ctr">
+                    <a:lnL w="9525" cap="flat" cmpd="sng" algn="ctr">
+                      <a:solidFill>
+                        <a:srgbClr val="CFE9FE"/>
+                      </a:solidFill>
+                      <a:prstDash val="solid"/>
+                      <a:round/>
+                      <a:headEnd type="none" w="med" len="med"/>
+                      <a:tailEnd type="none" w="med" len="med"/>
+                    </a:lnL>
+                    <a:lnR w="9525" cap="flat" cmpd="sng" algn="ctr">
+                      <a:solidFill>
+                        <a:srgbClr val="CFE9FE"/>
+                      </a:solidFill>
+                      <a:prstDash val="solid"/>
+                      <a:round/>
+                      <a:headEnd type="none" w="med" len="med"/>
+                      <a:tailEnd type="none" w="med" len="med"/>
+                    </a:lnR>
+                    <a:lnT w="9525" cap="flat" cmpd="sng" algn="ctr">
+                      <a:solidFill>
+                        <a:srgbClr val="CFE9FE"/>
+                      </a:solidFill>
+                      <a:prstDash val="solid"/>
+                      <a:round/>
+                      <a:headEnd type="none" w="med" len="med"/>
+                      <a:tailEnd type="none" w="med" len="med"/>
+                    </a:lnT>
+                    <a:lnB w="9525" cap="flat" cmpd="sng" algn="ctr">
+                      <a:solidFill>
+                        <a:srgbClr val="CFE9FE"/>
+                      </a:solidFill>
+                      <a:prstDash val="solid"/>
+                      <a:round/>
+                      <a:headEnd type="none" w="med" len="med"/>
+                      <a:tailEnd type="none" w="med" len="med"/>
+                    </a:lnB>
+                    <a:solidFill>
+                      <a:schemeClr val="bg2"/>
+                    </a:solidFill>
+                  </a:tcPr>
+                </a:tc>
+                <a:tc>
+                  <a:txBody>
+                    <a:bodyPr/>
+                    <a:lstStyle/>
+                    <a:p>
+                      <a:pPr indent="0" marL="0">
+                        <a:buNone/>
+                      </a:pPr>
+                      <a:r>
+                        <a:rPr lang="en-US" sz="1300" dirty="0">
+                          <a:solidFill>
+                            <a:schemeClr val="tx1"/>
+                          </a:solidFill>
+                        </a:rPr>
+                        <a:t>Case: Id, Amount, IsWon, region</a:t>
+                      </a:r>
+                      <a:endParaRPr lang="en-US" sz="1300" dirty="0"/>
+                    </a:p>
+                  </a:txBody>
+                  <a:tcPr marL="91440" marR="91440" marT="36576" marB="36576" anchor="ctr">
+                    <a:lnL w="9525" cap="flat" cmpd="sng" algn="ctr">
+                      <a:solidFill>
+                        <a:srgbClr val="CFE9FE"/>
+                      </a:solidFill>
+                      <a:prstDash val="solid"/>
+                      <a:round/>
+                      <a:headEnd type="none" w="med" len="med"/>
+                      <a:tailEnd type="none" w="med" len="med"/>
+                    </a:lnL>
+                    <a:lnR w="9525" cap="flat" cmpd="sng" algn="ctr">
+                      <a:solidFill>
+                        <a:srgbClr val="CFE9FE"/>
+                      </a:solidFill>
+                      <a:prstDash val="solid"/>
+                      <a:round/>
+                      <a:headEnd type="none" w="med" len="med"/>
+                      <a:tailEnd type="none" w="med" len="med"/>
+                    </a:lnR>
+                    <a:lnT w="9525" cap="flat" cmpd="sng" algn="ctr">
+                      <a:solidFill>
+                        <a:srgbClr val="CFE9FE"/>
+                      </a:solidFill>
+                      <a:prstDash val="solid"/>
+                      <a:round/>
+                      <a:headEnd type="none" w="med" len="med"/>
+                      <a:tailEnd type="none" w="med" len="med"/>
+                    </a:lnT>
+                    <a:lnB w="9525" cap="flat" cmpd="sng" algn="ctr">
+                      <a:solidFill>
+                        <a:srgbClr val="CFE9FE"/>
+                      </a:solidFill>
+                      <a:prstDash val="solid"/>
+                      <a:round/>
+                      <a:headEnd type="none" w="med" len="med"/>
+                      <a:tailEnd type="none" w="med" len="med"/>
+                    </a:lnB>
+                    <a:solidFill>
+                      <a:schemeClr val="bg2"/>
+                    </a:solidFill>
+                  </a:tcPr>
+                </a:tc>
+              </a:tr>
+              <a:tr h="384048">
+                <a:tc>
+                  <a:txBody>
+                    <a:bodyPr/>
+                    <a:lstStyle/>
+                    <a:p>
+                      <a:pPr indent="0" marL="0">
+                        <a:buNone/>
+                      </a:pPr>
+                      <a:r>
+                        <a:rPr lang="en-US" sz="1300" dirty="0">
+                          <a:solidFill>
+                            <a:schemeClr val="tx1"/>
+                          </a:solidFill>
+                        </a:rPr>
+                        <a:t>OpportunityHistory</a:t>
+                      </a:r>
+                      <a:endParaRPr lang="en-US" sz="1300" dirty="0"/>
+                    </a:p>
+                  </a:txBody>
+                  <a:tcPr marL="91440" marR="91440" marT="36576" marB="36576" anchor="ctr">
+                    <a:lnL w="9525" cap="flat" cmpd="sng" algn="ctr">
+                      <a:solidFill>
+                        <a:srgbClr val="CFE9FE"/>
+                      </a:solidFill>
+                      <a:prstDash val="solid"/>
+                      <a:round/>
+                      <a:headEnd type="none" w="med" len="med"/>
+                      <a:tailEnd type="none" w="med" len="med"/>
+                    </a:lnL>
+                    <a:lnR w="9525" cap="flat" cmpd="sng" algn="ctr">
+                      <a:solidFill>
+                        <a:srgbClr val="CFE9FE"/>
+                      </a:solidFill>
+                      <a:prstDash val="solid"/>
+                      <a:round/>
+                      <a:headEnd type="none" w="med" len="med"/>
+                      <a:tailEnd type="none" w="med" len="med"/>
+                    </a:lnR>
+                    <a:lnT w="9525" cap="flat" cmpd="sng" algn="ctr">
+                      <a:solidFill>
+                        <a:srgbClr val="CFE9FE"/>
+                      </a:solidFill>
+                      <a:prstDash val="solid"/>
+                      <a:round/>
+                      <a:headEnd type="none" w="med" len="med"/>
+                      <a:tailEnd type="none" w="med" len="med"/>
+                    </a:lnT>
+                    <a:lnB w="9525" cap="flat" cmpd="sng" algn="ctr">
+                      <a:solidFill>
+                        <a:srgbClr val="CFE9FE"/>
+                      </a:solidFill>
+                      <a:prstDash val="solid"/>
+                      <a:round/>
+                      <a:headEnd type="none" w="med" len="med"/>
+                      <a:tailEnd type="none" w="med" len="med"/>
+                    </a:lnB>
+                    <a:solidFill>
+                      <a:schemeClr val="bg1"/>
+                    </a:solidFill>
+                  </a:tcPr>
+                </a:tc>
+                <a:tc>
+                  <a:txBody>
+                    <a:bodyPr/>
+                    <a:lstStyle/>
+                    <a:p>
+                      <a:pPr indent="0" marL="0">
+                        <a:buNone/>
+                      </a:pPr>
+                      <a:r>
+                        <a:rPr lang="en-US" sz="1300" dirty="0">
+                          <a:solidFill>
+                            <a:schemeClr val="tx1"/>
+                          </a:solidFill>
+                        </a:rPr>
+                        <a:t>Stage events: StageName, CreatedDate</a:t>
+                      </a:r>
+                      <a:endParaRPr lang="en-US" sz="1300" dirty="0"/>
+                    </a:p>
+                  </a:txBody>
+                  <a:tcPr marL="91440" marR="91440" marT="36576" marB="36576" anchor="ctr">
+                    <a:lnL w="9525" cap="flat" cmpd="sng" algn="ctr">
+                      <a:solidFill>
+                        <a:srgbClr val="CFE9FE"/>
+                      </a:solidFill>
+                      <a:prstDash val="solid"/>
+                      <a:round/>
+                      <a:headEnd type="none" w="med" len="med"/>
+                      <a:tailEnd type="none" w="med" len="med"/>
+                    </a:lnL>
+                    <a:lnR w="9525" cap="flat" cmpd="sng" algn="ctr">
+                      <a:solidFill>
+                        <a:srgbClr val="CFE9FE"/>
+                      </a:solidFill>
+                      <a:prstDash val="solid"/>
+                      <a:round/>
+                      <a:headEnd type="none" w="med" len="med"/>
+                      <a:tailEnd type="none" w="med" len="med"/>
+                    </a:lnR>
+                    <a:lnT w="9525" cap="flat" cmpd="sng" algn="ctr">
+                      <a:solidFill>
+                        <a:srgbClr val="CFE9FE"/>
+                      </a:solidFill>
+                      <a:prstDash val="solid"/>
+                      <a:round/>
+                      <a:headEnd type="none" w="med" len="med"/>
+                      <a:tailEnd type="none" w="med" len="med"/>
+                    </a:lnT>
+                    <a:lnB w="9525" cap="flat" cmpd="sng" algn="ctr">
+                      <a:solidFill>
+                        <a:srgbClr val="CFE9FE"/>
+                      </a:solidFill>
+                      <a:prstDash val="solid"/>
+                      <a:round/>
+                      <a:headEnd type="none" w="med" len="med"/>
+                      <a:tailEnd type="none" w="med" len="med"/>
+                    </a:lnB>
+                    <a:solidFill>
+                      <a:schemeClr val="bg1"/>
+                    </a:solidFill>
+                  </a:tcPr>
+                </a:tc>
+              </a:tr>
+              <a:tr h="384048">
+                <a:tc>
+                  <a:txBody>
+                    <a:bodyPr/>
+                    <a:lstStyle/>
+                    <a:p>
+                      <a:pPr indent="0" marL="0">
+                        <a:buNone/>
+                      </a:pPr>
+                      <a:r>
+                        <a:rPr lang="en-US" sz="1300" dirty="0">
+                          <a:solidFill>
+                            <a:schemeClr val="tx1"/>
+                          </a:solidFill>
+                        </a:rPr>
+                        <a:t>Task (WhatId)</a:t>
+                      </a:r>
+                      <a:endParaRPr lang="en-US" sz="1300" dirty="0"/>
+                    </a:p>
+                  </a:txBody>
+                  <a:tcPr marL="91440" marR="91440" marT="36576" marB="36576" anchor="ctr">
+                    <a:lnL w="9525" cap="flat" cmpd="sng" algn="ctr">
+                      <a:solidFill>
+                        <a:srgbClr val="CFE9FE"/>
+                      </a:solidFill>
+                      <a:prstDash val="solid"/>
+                      <a:round/>
+                      <a:headEnd type="none" w="med" len="med"/>
+                      <a:tailEnd type="none" w="med" len="med"/>
+                    </a:lnL>
+                    <a:lnR w="9525" cap="flat" cmpd="sng" algn="ctr">
+                      <a:solidFill>
+                        <a:srgbClr val="CFE9FE"/>
+                      </a:solidFill>
+                      <a:prstDash val="solid"/>
+                      <a:round/>
+                      <a:headEnd type="none" w="med" len="med"/>
+                      <a:tailEnd type="none" w="med" len="med"/>
+                    </a:lnR>
+                    <a:lnT w="9525" cap="flat" cmpd="sng" algn="ctr">
+                      <a:solidFill>
+                        <a:srgbClr val="CFE9FE"/>
+                      </a:solidFill>
+                      <a:prstDash val="solid"/>
+                      <a:round/>
+                      <a:headEnd type="none" w="med" len="med"/>
+                      <a:tailEnd type="none" w="med" len="med"/>
+                    </a:lnT>
+                    <a:lnB w="9525" cap="flat" cmpd="sng" algn="ctr">
+                      <a:solidFill>
+                        <a:srgbClr val="CFE9FE"/>
+                      </a:solidFill>
+                      <a:prstDash val="solid"/>
+                      <a:round/>
+                      <a:headEnd type="none" w="med" len="med"/>
+                      <a:tailEnd type="none" w="med" len="med"/>
+                    </a:lnB>
+                    <a:solidFill>
+                      <a:schemeClr val="bg2"/>
+                    </a:solidFill>
+                  </a:tcPr>
+                </a:tc>
+                <a:tc>
+                  <a:txBody>
+                    <a:bodyPr/>
+                    <a:lstStyle/>
+                    <a:p>
+                      <a:pPr indent="0" marL="0">
+                        <a:buNone/>
+                      </a:pPr>
+                      <a:r>
+                        <a:rPr lang="en-US" sz="1300" dirty="0">
+                          <a:solidFill>
+                            <a:schemeClr val="tx1"/>
+                          </a:solidFill>
+                        </a:rPr>
+                        <a:t>Activities: Subject, created → completed</a:t>
+                      </a:r>
+                      <a:endParaRPr lang="en-US" sz="1300" dirty="0"/>
+                    </a:p>
+                  </a:txBody>
+                  <a:tcPr marL="91440" marR="91440" marT="36576" marB="36576" anchor="ctr">
+                    <a:lnL w="9525" cap="flat" cmpd="sng" algn="ctr">
+                      <a:solidFill>
+                        <a:srgbClr val="CFE9FE"/>
+                      </a:solidFill>
+                      <a:prstDash val="solid"/>
+                      <a:round/>
+                      <a:headEnd type="none" w="med" len="med"/>
+                      <a:tailEnd type="none" w="med" len="med"/>
+                    </a:lnL>
+                    <a:lnR w="9525" cap="flat" cmpd="sng" algn="ctr">
+                      <a:solidFill>
+                        <a:srgbClr val="CFE9FE"/>
+                      </a:solidFill>
+                      <a:prstDash val="solid"/>
+                      <a:round/>
+                      <a:headEnd type="none" w="med" len="med"/>
+                      <a:tailEnd type="none" w="med" len="med"/>
+                    </a:lnR>
+                    <a:lnT w="9525" cap="flat" cmpd="sng" algn="ctr">
+                      <a:solidFill>
+                        <a:srgbClr val="CFE9FE"/>
+                      </a:solidFill>
+                      <a:prstDash val="solid"/>
+                      <a:round/>
+                      <a:headEnd type="none" w="med" len="med"/>
+                      <a:tailEnd type="none" w="med" len="med"/>
+                    </a:lnT>
+                    <a:lnB w="9525" cap="flat" cmpd="sng" algn="ctr">
+                      <a:solidFill>
+                        <a:srgbClr val="CFE9FE"/>
+                      </a:solidFill>
+                      <a:prstDash val="solid"/>
+                      <a:round/>
+                      <a:headEnd type="none" w="med" len="med"/>
+                      <a:tailEnd type="none" w="med" len="med"/>
+                    </a:lnB>
+                    <a:solidFill>
+                      <a:schemeClr val="bg2"/>
+                    </a:solidFill>
+                  </a:tcPr>
+                </a:tc>
+              </a:tr>
+              <a:tr h="384048">
+                <a:tc>
+                  <a:txBody>
+                    <a:bodyPr/>
+                    <a:lstStyle/>
+                    <a:p>
+                      <a:pPr indent="0" marL="0">
+                        <a:buNone/>
+                      </a:pPr>
+                      <a:r>
+                        <a:rPr lang="en-US" sz="1300" dirty="0">
+                          <a:solidFill>
+                            <a:schemeClr val="tx1"/>
+                          </a:solidFill>
+                        </a:rPr>
+                        <a:t>Lead (ConvertedOpportunityId)</a:t>
+                      </a:r>
+                      <a:endParaRPr lang="en-US" sz="1300" dirty="0"/>
+                    </a:p>
+                  </a:txBody>
+                  <a:tcPr marL="91440" marR="91440" marT="36576" marB="36576" anchor="ctr">
+                    <a:lnL w="9525" cap="flat" cmpd="sng" algn="ctr">
+                      <a:solidFill>
+                        <a:srgbClr val="CFE9FE"/>
+                      </a:solidFill>
+                      <a:prstDash val="solid"/>
+                      <a:round/>
+                      <a:headEnd type="none" w="med" len="med"/>
+                      <a:tailEnd type="none" w="med" len="med"/>
+                    </a:lnL>
+                    <a:lnR w="9525" cap="flat" cmpd="sng" algn="ctr">
+                      <a:solidFill>
+                        <a:srgbClr val="CFE9FE"/>
+                      </a:solidFill>
+                      <a:prstDash val="solid"/>
+                      <a:round/>
+                      <a:headEnd type="none" w="med" len="med"/>
+                      <a:tailEnd type="none" w="med" len="med"/>
+                    </a:lnR>
+                    <a:lnT w="9525" cap="flat" cmpd="sng" algn="ctr">
+                      <a:solidFill>
+                        <a:srgbClr val="CFE9FE"/>
+                      </a:solidFill>
+                      <a:prstDash val="solid"/>
+                      <a:round/>
+                      <a:headEnd type="none" w="med" len="med"/>
+                      <a:tailEnd type="none" w="med" len="med"/>
+                    </a:lnT>
+                    <a:lnB w="9525" cap="flat" cmpd="sng" algn="ctr">
+                      <a:solidFill>
+                        <a:srgbClr val="CFE9FE"/>
+                      </a:solidFill>
+                      <a:prstDash val="solid"/>
+                      <a:round/>
+                      <a:headEnd type="none" w="med" len="med"/>
+                      <a:tailEnd type="none" w="med" len="med"/>
+                    </a:lnB>
+                    <a:solidFill>
+                      <a:schemeClr val="bg1"/>
+                    </a:solidFill>
+                  </a:tcPr>
+                </a:tc>
+                <a:tc>
+                  <a:txBody>
+                    <a:bodyPr/>
+                    <a:lstStyle/>
+                    <a:p>
+                      <a:pPr indent="0" marL="0">
+                        <a:buNone/>
+                      </a:pPr>
+                      <a:r>
+                        <a:rPr lang="en-US" sz="1300" dirty="0">
+                          <a:solidFill>
+                            <a:schemeClr val="tx1"/>
+                          </a:solidFill>
+                        </a:rPr>
+                        <a:t>Lead Created event</a:t>
+                      </a:r>
+                      <a:endParaRPr lang="en-US" sz="1300" dirty="0"/>
+                    </a:p>
+                  </a:txBody>
+                  <a:tcPr marL="91440" marR="91440" marT="36576" marB="36576" anchor="ctr">
+                    <a:lnL w="9525" cap="flat" cmpd="sng" algn="ctr">
+                      <a:solidFill>
+                        <a:srgbClr val="CFE9FE"/>
+                      </a:solidFill>
+                      <a:prstDash val="solid"/>
+                      <a:round/>
+                      <a:headEnd type="none" w="med" len="med"/>
+                      <a:tailEnd type="none" w="med" len="med"/>
+                    </a:lnL>
+                    <a:lnR w="9525" cap="flat" cmpd="sng" algn="ctr">
+                      <a:solidFill>
+                        <a:srgbClr val="CFE9FE"/>
+                      </a:solidFill>
+                      <a:prstDash val="solid"/>
+                      <a:round/>
+                      <a:headEnd type="none" w="med" len="med"/>
+                      <a:tailEnd type="none" w="med" len="med"/>
+                    </a:lnR>
+                    <a:lnT w="9525" cap="flat" cmpd="sng" algn="ctr">
+                      <a:solidFill>
+                        <a:srgbClr val="CFE9FE"/>
+                      </a:solidFill>
+                      <a:prstDash val="solid"/>
+                      <a:round/>
+                      <a:headEnd type="none" w="med" len="med"/>
+                      <a:tailEnd type="none" w="med" len="med"/>
+                    </a:lnT>
+                    <a:lnB w="9525" cap="flat" cmpd="sng" algn="ctr">
+                      <a:solidFill>
+                        <a:srgbClr val="CFE9FE"/>
+                      </a:solidFill>
+                      <a:prstDash val="solid"/>
+                      <a:round/>
+                      <a:headEnd type="none" w="med" len="med"/>
+                      <a:tailEnd type="none" w="med" len="med"/>
+                    </a:lnB>
+                    <a:solidFill>
+                      <a:schemeClr val="bg1"/>
+                    </a:solidFill>
+                  </a:tcPr>
+                </a:tc>
+              </a:tr>
+            </a:tbl>
+          </a:graphicData>
+        </a:graphic>
+      </p:graphicFrame>
+      <p:sp>
+        <p:nvSpPr>
+          <p:cNvPr id="13" name="Code caption"/>
           <p:cNvSpPr txBox="1"/>
           <p:nvPr/>
         </p:nvSpPr>
@@ -3086,7 +2829,7 @@
                   <a:schemeClr val="tx2"/>
                 </a:solidFill>
               </a:rPr>
-              <a:t>four SOQL queries over the REST API, signed by the Salesforce CLI session. Opportunity Id becomes the case ID.</a:t>
+              <a:t>four SOQL queries over the REST API, signed by the Salesforce CLI session. Output: CSV and XES.</a:t>
             </a:r>
             <a:endParaRPr lang="en-US" sz="1400" dirty="0"/>
           </a:p>
@@ -3094,7 +2837,7 @@
       </p:sp>
       <p:sp>
         <p:nvSpPr>
-          <p:cNvPr id="13" name="Popup 1 box"/>
+          <p:cNvPr id="14" name="Popup 1 box"/>
           <p:cNvSpPr/>
           <p:nvPr/>
         </p:nvSpPr>
@@ -3128,7 +2871,7 @@
       </p:sp>
       <p:sp>
         <p:nvSpPr>
-          <p:cNvPr id="14" name="Popup 1 badge"/>
+          <p:cNvPr id="15" name="Popup 1 badge"/>
           <p:cNvSpPr/>
           <p:nvPr/>
         </p:nvSpPr>
@@ -3148,7 +2891,7 @@
       </p:sp>
       <p:sp>
         <p:nvSpPr>
-          <p:cNvPr id="15" name="Popup 1 number"/>
+          <p:cNvPr id="16" name="Popup 1 number"/>
           <p:cNvSpPr txBox="1"/>
           <p:nvPr/>
         </p:nvSpPr>
@@ -3184,7 +2927,7 @@
       </p:sp>
       <p:sp>
         <p:nvSpPr>
-          <p:cNvPr id="16" name="Popup 1 label"/>
+          <p:cNvPr id="17" name="Popup 1 label"/>
           <p:cNvSpPr txBox="1"/>
           <p:nvPr/>
         </p:nvSpPr>
@@ -3220,7 +2963,7 @@
       </p:sp>
       <p:sp>
         <p:nvSpPr>
-          <p:cNvPr id="17" name="Popup 2 box"/>
+          <p:cNvPr id="18" name="Popup 2 box"/>
           <p:cNvSpPr/>
           <p:nvPr/>
         </p:nvSpPr>
@@ -3254,7 +2997,7 @@
       </p:sp>
       <p:sp>
         <p:nvSpPr>
-          <p:cNvPr id="18" name="Popup 2 badge"/>
+          <p:cNvPr id="19" name="Popup 2 badge"/>
           <p:cNvSpPr/>
           <p:nvPr/>
         </p:nvSpPr>
@@ -3274,7 +3017,7 @@
       </p:sp>
       <p:sp>
         <p:nvSpPr>
-          <p:cNvPr id="19" name="Popup 2 number"/>
+          <p:cNvPr id="20" name="Popup 2 number"/>
           <p:cNvSpPr txBox="1"/>
           <p:nvPr/>
         </p:nvSpPr>
@@ -3310,7 +3053,7 @@
       </p:sp>
       <p:sp>
         <p:nvSpPr>
-          <p:cNvPr id="20" name="Popup 2 label"/>
+          <p:cNvPr id="21" name="Popup 2 label"/>
           <p:cNvSpPr txBox="1"/>
           <p:nvPr/>
         </p:nvSpPr>
@@ -3346,14 +3089,14 @@
       </p:sp>
       <p:sp>
         <p:nvSpPr>
-          <p:cNvPr id="21" name="Popup 3 box"/>
+          <p:cNvPr id="22" name="Popup 3 box"/>
           <p:cNvSpPr/>
           <p:nvPr/>
         </p:nvSpPr>
         <p:spPr>
           <a:xfrm>
-            <a:off x="8915400" y="1307592"/>
-            <a:ext cx="2606040" cy="365760"/>
+            <a:off x="9098280" y="1307592"/>
+            <a:ext cx="2423160" cy="365760"/>
           </a:xfrm>
           <a:prstGeom prst="roundRect">
             <a:avLst>
@@ -3380,13 +3123,13 @@
       </p:sp>
       <p:sp>
         <p:nvSpPr>
-          <p:cNvPr id="22" name="Popup 3 badge"/>
+          <p:cNvPr id="23" name="Popup 3 badge"/>
           <p:cNvSpPr/>
           <p:nvPr/>
         </p:nvSpPr>
         <p:spPr>
           <a:xfrm>
-            <a:off x="8970264" y="1353312"/>
+            <a:off x="9153144" y="1353312"/>
             <a:ext cx="274320" cy="274320"/>
           </a:xfrm>
           <a:prstGeom prst="ellipse">
@@ -3400,13 +3143,13 @@
       </p:sp>
       <p:sp>
         <p:nvSpPr>
-          <p:cNvPr id="23" name="Popup 3 number"/>
+          <p:cNvPr id="24" name="Popup 3 number"/>
           <p:cNvSpPr txBox="1"/>
           <p:nvPr/>
         </p:nvSpPr>
         <p:spPr>
           <a:xfrm>
-            <a:off x="8970264" y="1353312"/>
+            <a:off x="9153144" y="1353312"/>
             <a:ext cx="274320" cy="274320"/>
           </a:xfrm>
           <a:prstGeom prst="rect">
@@ -3436,14 +3179,14 @@
       </p:sp>
       <p:sp>
         <p:nvSpPr>
-          <p:cNvPr id="24" name="Popup 3 label"/>
+          <p:cNvPr id="25" name="Popup 3 label"/>
           <p:cNvSpPr txBox="1"/>
           <p:nvPr/>
         </p:nvSpPr>
         <p:spPr>
           <a:xfrm>
-            <a:off x="9317736" y="1307592"/>
-            <a:ext cx="2148840" cy="365760"/>
+            <a:off x="9500616" y="1307592"/>
+            <a:ext cx="1965960" cy="365760"/>
           </a:xfrm>
           <a:prstGeom prst="rect">
             <a:avLst/>
@@ -3464,7 +3207,7 @@
                   <a:schemeClr val="tx2"/>
                 </a:solidFill>
               </a:rPr>
-              <a:t>SOQL over REST via CLI</a:t>
+              <a:t>SOQL via the CLI session</a:t>
             </a:r>
             <a:endParaRPr lang="en-US" sz="1200" dirty="0"/>
           </a:p>
@@ -3472,14 +3215,14 @@
       </p:sp>
       <p:sp>
         <p:nvSpPr>
-          <p:cNvPr id="25" name="Popup 4 box"/>
+          <p:cNvPr id="26" name="Popup 4 box"/>
           <p:cNvSpPr/>
           <p:nvPr/>
         </p:nvSpPr>
         <p:spPr>
           <a:xfrm>
-            <a:off x="9601200" y="2917210"/>
-            <a:ext cx="1920240" cy="365760"/>
+            <a:off x="9372600" y="3136392"/>
+            <a:ext cx="2148840" cy="365760"/>
           </a:xfrm>
           <a:prstGeom prst="roundRect">
             <a:avLst>
@@ -3506,13 +3249,13 @@
       </p:sp>
       <p:sp>
         <p:nvSpPr>
-          <p:cNvPr id="26" name="Popup 4 badge"/>
+          <p:cNvPr id="27" name="Popup 4 badge"/>
           <p:cNvSpPr/>
           <p:nvPr/>
         </p:nvSpPr>
         <p:spPr>
           <a:xfrm>
-            <a:off x="9656064" y="2962930"/>
+            <a:off x="9427464" y="3182112"/>
             <a:ext cx="274320" cy="274320"/>
           </a:xfrm>
           <a:prstGeom prst="ellipse">
@@ -3526,13 +3269,13 @@
       </p:sp>
       <p:sp>
         <p:nvSpPr>
-          <p:cNvPr id="27" name="Popup 4 number"/>
+          <p:cNvPr id="28" name="Popup 4 number"/>
           <p:cNvSpPr txBox="1"/>
           <p:nvPr/>
         </p:nvSpPr>
         <p:spPr>
           <a:xfrm>
-            <a:off x="9656064" y="2962930"/>
+            <a:off x="9427464" y="3182112"/>
             <a:ext cx="274320" cy="274320"/>
           </a:xfrm>
           <a:prstGeom prst="rect">
@@ -3562,14 +3305,14 @@
       </p:sp>
       <p:sp>
         <p:nvSpPr>
-          <p:cNvPr id="28" name="Popup 4 label"/>
+          <p:cNvPr id="29" name="Popup 4 label"/>
           <p:cNvSpPr txBox="1"/>
           <p:nvPr/>
         </p:nvSpPr>
         <p:spPr>
           <a:xfrm>
-            <a:off x="10003536" y="2917210"/>
-            <a:ext cx="1463040" cy="365760"/>
+            <a:off x="9774936" y="3136392"/>
+            <a:ext cx="1691640" cy="365760"/>
           </a:xfrm>
           <a:prstGeom prst="rect">
             <a:avLst/>
@@ -3590,133 +3333,7 @@
                   <a:schemeClr val="tx2"/>
                 </a:solidFill>
               </a:rPr>
-              <a:t>History → events</a:t>
-            </a:r>
-            <a:endParaRPr lang="en-US" sz="1200" dirty="0"/>
-          </a:p>
-        </p:txBody>
-      </p:sp>
-      <p:sp>
-        <p:nvSpPr>
-          <p:cNvPr id="29" name="Popup 5 box"/>
-          <p:cNvSpPr/>
-          <p:nvPr/>
-        </p:nvSpPr>
-        <p:spPr>
-          <a:xfrm>
-            <a:off x="9372600" y="3679363"/>
-            <a:ext cx="2148840" cy="365760"/>
-          </a:xfrm>
-          <a:prstGeom prst="roundRect">
-            <a:avLst>
-              <a:gd name="adj" fmla="val 20000"/>
-            </a:avLst>
-          </a:prstGeom>
-          <a:solidFill>
-            <a:schemeClr val="bg1"/>
-          </a:solidFill>
-          <a:ln w="19050">
-            <a:solidFill>
-              <a:schemeClr val="accent1"/>
-            </a:solidFill>
-            <a:prstDash val="solid"/>
-          </a:ln>
-          <a:effectLst>
-            <a:outerShdw sx="100000" sy="100000" kx="0" ky="0" algn="bl" rotWithShape="0" blurRad="50800" dist="25400" dir="5400000">
-              <a:srgbClr val="000000">
-                <a:alpha val="25000"/>
-              </a:srgbClr>
-            </a:outerShdw>
-          </a:effectLst>
-        </p:spPr>
-      </p:sp>
-      <p:sp>
-        <p:nvSpPr>
-          <p:cNvPr id="30" name="Popup 5 badge"/>
-          <p:cNvSpPr/>
-          <p:nvPr/>
-        </p:nvSpPr>
-        <p:spPr>
-          <a:xfrm>
-            <a:off x="9427464" y="3725083"/>
-            <a:ext cx="274320" cy="274320"/>
-          </a:xfrm>
-          <a:prstGeom prst="ellipse">
-            <a:avLst/>
-          </a:prstGeom>
-          <a:solidFill>
-            <a:schemeClr val="accent4"/>
-          </a:solidFill>
-          <a:ln/>
-        </p:spPr>
-      </p:sp>
-      <p:sp>
-        <p:nvSpPr>
-          <p:cNvPr id="31" name="Popup 5 number"/>
-          <p:cNvSpPr txBox="1"/>
-          <p:nvPr/>
-        </p:nvSpPr>
-        <p:spPr>
-          <a:xfrm>
-            <a:off x="9427464" y="3725083"/>
-            <a:ext cx="274320" cy="274320"/>
-          </a:xfrm>
-          <a:prstGeom prst="rect">
-            <a:avLst/>
-          </a:prstGeom>
-          <a:noFill/>
-          <a:ln/>
-        </p:spPr>
-        <p:txBody>
-          <a:bodyPr wrap="square" lIns="0" tIns="0" rIns="0" bIns="0" rtlCol="0" anchor="ctr"/>
-          <a:lstStyle/>
-          <a:p>
-            <a:pPr algn="ctr" indent="0" marL="0">
-              <a:buNone/>
-            </a:pPr>
-            <a:r>
-              <a:rPr lang="en-US" sz="1200" b="1" dirty="0">
-                <a:solidFill>
-                  <a:schemeClr val="bg1"/>
-                </a:solidFill>
-              </a:rPr>
-              <a:t>5</a:t>
-            </a:r>
-            <a:endParaRPr lang="en-US" sz="1200" dirty="0"/>
-          </a:p>
-        </p:txBody>
-      </p:sp>
-      <p:sp>
-        <p:nvSpPr>
-          <p:cNvPr id="32" name="Popup 5 label"/>
-          <p:cNvSpPr txBox="1"/>
-          <p:nvPr/>
-        </p:nvSpPr>
-        <p:spPr>
-          <a:xfrm>
-            <a:off x="9774936" y="3679363"/>
-            <a:ext cx="1691640" cy="365760"/>
-          </a:xfrm>
-          <a:prstGeom prst="rect">
-            <a:avLst/>
-          </a:prstGeom>
-          <a:noFill/>
-          <a:ln/>
-        </p:spPr>
-        <p:txBody>
-          <a:bodyPr wrap="square" lIns="0" tIns="0" rIns="0" bIns="0" rtlCol="0" anchor="ctr"/>
-          <a:lstStyle/>
-          <a:p>
-            <a:pPr indent="0" marL="0">
-              <a:buNone/>
-            </a:pPr>
-            <a:r>
-              <a:rPr lang="en-US" sz="1200" b="1" dirty="0">
-                <a:solidFill>
-                  <a:schemeClr val="tx2"/>
-                </a:solidFill>
-              </a:rPr>
-              <a:t>Tasks join on WhatId</a:t>
+              <a:t>Objects → events</a:t>
             </a:r>
             <a:endParaRPr lang="en-US" sz="1200" dirty="0"/>
           </a:p>
@@ -3824,7 +3441,7 @@
                   <a:schemeClr val="tx2"/>
                 </a:solidFill>
               </a:rPr>
-              <a:t>Everything is live and open to inspect</a:t>
+              <a:t>Hosted demo, live extraction proof and source code</a:t>
             </a:r>
             <a:endParaRPr lang="en-US" sz="3000" dirty="0"/>
           </a:p>

</xml_diff>

<commit_message>
Site: collapse to an overview and a process analysis page
The business case and live Salesforce run become sections of the
overview; old /value-case.html and /live.html redirect to them. Nav is
the same on both pages and the site name links home. Also removes a
duplicated nav block that ran inside the value update.

Co-Authored-By: Claude Opus 5.5 <noreply@anthropic.com>
</commit_message>
<xml_diff>
--- a/deck/salesforce-process-intelligence-tech-setup.pptx
+++ b/deck/salesforce-process-intelligence-tech-setup.pptx
@@ -109,7 +109,7 @@
   <p:extLst>
     <p:ext uri="{521415D9-36F7-43E2-AB2F-B90AF26B5E84}">
       <p14:sectionLst xmlns:p14="http://schemas.microsoft.com/office/powerpoint/2010/main">
-        <p14:section name="Tech setup" id="{a3890b9e-df38-acaf-47f4-752a83dfc439}">
+        <p14:section name="Tech setup" id="{4b915ca9-76f3-5f82-9b71-1e5dd0ed252a}">
           <p14:sldIdLst>
             <p14:sldId id="256"/>
             <p14:sldId id="257"/>
@@ -3555,7 +3555,7 @@
                   <a:schemeClr val="tx2"/>
                 </a:solidFill>
               </a:rPr>
-              <a:t>Landing page and value items</a:t>
+              <a:t>Overview: value items and business case</a:t>
             </a:r>
             <a:endParaRPr lang="en-US" sz="1600" dirty="0"/>
           </a:p>
@@ -3712,7 +3712,7 @@
                   <a:schemeClr val="tx2"/>
                 </a:solidFill>
               </a:rPr>
-              <a:t>Process dashboard</a:t>
+              <a:t>Process analysis</a:t>
             </a:r>
             <a:endParaRPr lang="en-US" sz="1600" dirty="0"/>
           </a:p>
@@ -3869,7 +3869,7 @@
                   <a:schemeClr val="tx2"/>
                 </a:solidFill>
               </a:rPr>
-              <a:t>Value case one-pager</a:t>
+              <a:t>Business case (re-quotes)</a:t>
             </a:r>
             <a:endParaRPr lang="en-US" sz="1600" dirty="0"/>
           </a:p>
@@ -3912,7 +3912,7 @@
                   </a:extLst>
                 </a:hlinkClick>
               </a:rPr>
-              <a:t>salesforce-process-intelligence.vercel.app/value-case.html</a:t>
+              <a:t>salesforce-process-intelligence.vercel.app/#business-case</a:t>
             </a:r>
             <a:endParaRPr lang="en-US" sz="1400" dirty="0"/>
           </a:p>
@@ -4026,7 +4026,7 @@
                   <a:schemeClr val="tx2"/>
                 </a:solidFill>
               </a:rPr>
-              <a:t>Live Salesforce extract</a:t>
+              <a:t>Live Salesforce run and downloads</a:t>
             </a:r>
             <a:endParaRPr lang="en-US" sz="1600" dirty="0"/>
           </a:p>
@@ -4069,7 +4069,7 @@
                   </a:extLst>
                 </a:hlinkClick>
               </a:rPr>
-              <a:t>salesforce-process-intelligence.vercel.app/live.html</a:t>
+              <a:t>salesforce-process-intelligence.vercel.app/#live-run</a:t>
             </a:r>
             <a:endParaRPr lang="en-US" sz="1400" dirty="0"/>
           </a:p>

</xml_diff>

<commit_message>
Tech deck: QA pass and a prototype-to-production slide
- New slide: what the prototype proves, known limits, production path
- Links slide uses the current overview screenshot and site names
- Tighter title and subtitle wording

Co-Authored-By: Claude Opus 5.5 <noreply@anthropic.com>
</commit_message>
<xml_diff>
--- a/deck/salesforce-process-intelligence-tech-setup.pptx
+++ b/deck/salesforce-process-intelligence-tech-setup.pptx
@@ -8,9 +8,10 @@
     <p:sldId id="256" r:id="rId2"/>
     <p:sldId id="257" r:id="rId3"/>
     <p:sldId id="258" r:id="rId4"/>
+    <p:sldId id="259" r:id="rId5"/>
   </p:sldIdLst>
   <p:notesMasterIdLst>
-    <p:notesMasterId r:id="rId5"/>
+    <p:notesMasterId r:id="rId6"/>
   </p:notesMasterIdLst>
   <p:sldSz cx="12192000" cy="6858000"/>
   <p:notesSz cx="6858000" cy="12192000"/>
@@ -109,11 +110,12 @@
   <p:extLst>
     <p:ext uri="{521415D9-36F7-43E2-AB2F-B90AF26B5E84}">
       <p14:sectionLst xmlns:p14="http://schemas.microsoft.com/office/powerpoint/2010/main">
-        <p14:section name="Tech setup" id="{1b265442-65c7-34ef-e8b7-d4d25558a114}">
+        <p14:section name="Tech setup" id="{9a267680-d26b-ca61-99bb-a9964de8cc4d}">
           <p14:sldIdLst>
             <p14:sldId id="256"/>
             <p14:sldId id="257"/>
             <p14:sldId id="258"/>
+            <p14:sldId id="259"/>
           </p14:sldIdLst>
         </p14:section>
       </p14:sectionLst>
@@ -696,7 +698,7 @@
           <a:p>
             <a:r>
               <a:rPr lang="en-US" dirty="0"/>
-              <a:t>All of this is hosted. The repo has the pipeline, the seeding script and the README with the setup gotchas I hit on a new trial org.</a:t>
+              <a:t>The prototype proves the extraction and event-log design end to end on a real org. The limits are about event semantics and data, not plumbing. Production work is incremental refresh at volume, stable identifiers, approval history from the approval objects, and reconciliation so Finance can trust the numbers.</a:t>
             </a:r>
             <a:endParaRPr lang="en-US" dirty="0"/>
           </a:p>
@@ -720,6 +722,94 @@
             <a:fld id="{F7021451-1387-4CA6-816F-3879F97B5CBC}" type="slidenum">
               <a:rPr lang="en-US"/>
               <a:t>3</a:t>
+            </a:fld>
+            <a:endParaRPr lang="en-US"/>
+          </a:p>
+        </p:txBody>
+      </p:sp>
+    </p:spTree>
+    <p:extLst>
+      <p:ext uri="{BB962C8B-B14F-4D97-AF65-F5344CB8AC3E}">
+        <p14:creationId xmlns:p14="http://schemas.microsoft.com/office/powerpoint/2010/main" val="1024086991"/>
+      </p:ext>
+    </p:extLst>
+  </p:cSld>
+  <p:clrMapOvr>
+    <a:masterClrMapping/>
+  </p:clrMapOvr>
+</p:notes>
+</file>
+
+<file path=ppt/notesSlides/notesSlide4.xml><?xml version="1.0" encoding="utf-8"?>
+<p:notes xmlns:a="http://schemas.openxmlformats.org/drawingml/2006/main" xmlns:r="http://schemas.openxmlformats.org/officeDocument/2006/relationships" xmlns:p="http://schemas.openxmlformats.org/presentationml/2006/main">
+  <p:cSld>
+    <p:spTree>
+      <p:nvGrpSpPr>
+        <p:cNvPr id="1" name=""/>
+        <p:cNvGrpSpPr/>
+        <p:nvPr/>
+      </p:nvGrpSpPr>
+      <p:grpSpPr>
+        <a:xfrm>
+          <a:off x="0" y="0"/>
+          <a:ext cx="0" cy="0"/>
+          <a:chOff x="0" y="0"/>
+          <a:chExt cx="0" cy="0"/>
+        </a:xfrm>
+      </p:grpSpPr>
+      <p:sp>
+        <p:nvSpPr>
+          <p:cNvPr id="2" name="Slide Image Placeholder 1"/>
+          <p:cNvSpPr>
+            <a:spLocks noGrp="1" noRot="1" noChangeAspect="1"/>
+          </p:cNvSpPr>
+          <p:nvPr>
+            <p:ph type="sldImg"/>
+          </p:nvPr>
+        </p:nvSpPr>
+        <p:spPr/>
+      </p:sp>
+      <p:sp>
+        <p:nvSpPr>
+          <p:cNvPr id="3" name="Notes Placeholder 2"/>
+          <p:cNvSpPr>
+            <a:spLocks noGrp="1"/>
+          </p:cNvSpPr>
+          <p:nvPr>
+            <p:ph type="body" idx="1"/>
+          </p:nvPr>
+        </p:nvSpPr>
+        <p:spPr/>
+        <p:txBody>
+          <a:bodyPr/>
+          <a:lstStyle/>
+          <a:p>
+            <a:r>
+              <a:rPr lang="en-US" dirty="0"/>
+              <a:t>All of this is hosted. The overview carries the value items and business case; Data assets has the live run and every event log; the repo has the pipeline, the seeding script and the README with the setup gotchas from a new trial org.</a:t>
+            </a:r>
+            <a:endParaRPr lang="en-US" dirty="0"/>
+          </a:p>
+        </p:txBody>
+      </p:sp>
+      <p:sp>
+        <p:nvSpPr>
+          <p:cNvPr id="4" name="Slide Number Placeholder 3"/>
+          <p:cNvSpPr>
+            <a:spLocks noGrp="1"/>
+          </p:cNvSpPr>
+          <p:nvPr>
+            <p:ph type="sldNum" sz="quarter" idx="10"/>
+          </p:nvPr>
+        </p:nvSpPr>
+        <p:spPr/>
+        <p:txBody>
+          <a:bodyPr/>
+          <a:lstStyle/>
+          <a:p>
+            <a:fld id="{F7021451-1387-4CA6-816F-3879F97B5CBC}" type="slidenum">
+              <a:rPr lang="en-US"/>
+              <a:t>4</a:t>
             </a:fld>
             <a:endParaRPr lang="en-US"/>
           </a:p>
@@ -1666,7 +1756,7 @@
                   <a:schemeClr val="accent3"/>
                 </a:solidFill>
               </a:rPr>
-              <a:t>From a Salesforce org to Process Intelligence: the pipeline behind the demo</a:t>
+              <a:t>The pipeline behind the demo: Salesforce data to an event log</a:t>
             </a:r>
             <a:endParaRPr lang="en-US" sz="2000" dirty="0"/>
           </a:p>
@@ -1765,7 +1855,7 @@
                   <a:schemeClr val="tx2"/>
                 </a:solidFill>
               </a:rPr>
-              <a:t>Tech setup: from a Salesforce org to an event log</a:t>
+              <a:t>From a Salesforce org to an event log</a:t>
             </a:r>
             <a:endParaRPr lang="en-US" sz="3000" dirty="0"/>
           </a:p>
@@ -3441,6 +3531,606 @@
                   <a:schemeClr val="tx2"/>
                 </a:solidFill>
               </a:rPr>
+              <a:t>Prototype today, production next</a:t>
+            </a:r>
+            <a:endParaRPr lang="en-US" sz="3000" dirty="0"/>
+          </a:p>
+        </p:txBody>
+      </p:sp>
+      <p:sp>
+        <p:nvSpPr>
+          <p:cNvPr id="3" name="Lane 1 card"/>
+          <p:cNvSpPr/>
+          <p:nvPr/>
+        </p:nvSpPr>
+        <p:spPr>
+          <a:xfrm>
+            <a:off x="548640" y="1325880"/>
+            <a:ext cx="3529584" cy="3520440"/>
+          </a:xfrm>
+          <a:prstGeom prst="roundRect">
+            <a:avLst>
+              <a:gd name="adj" fmla="val 3117"/>
+            </a:avLst>
+          </a:prstGeom>
+          <a:solidFill>
+            <a:schemeClr val="bg2"/>
+          </a:solidFill>
+          <a:ln/>
+        </p:spPr>
+      </p:sp>
+      <p:sp>
+        <p:nvSpPr>
+          <p:cNvPr id="4" name="Lane 1 heading"/>
+          <p:cNvSpPr txBox="1"/>
+          <p:nvPr/>
+        </p:nvSpPr>
+        <p:spPr>
+          <a:xfrm>
+            <a:off x="777240" y="1508760"/>
+            <a:ext cx="3072384" cy="411480"/>
+          </a:xfrm>
+          <a:prstGeom prst="rect">
+            <a:avLst/>
+          </a:prstGeom>
+          <a:noFill/>
+          <a:ln/>
+        </p:spPr>
+        <p:txBody>
+          <a:bodyPr wrap="square" lIns="0" tIns="0" rIns="0" bIns="0" rtlCol="0" anchor="t"/>
+          <a:lstStyle/>
+          <a:p>
+            <a:pPr indent="0" marL="0">
+              <a:buNone/>
+            </a:pPr>
+            <a:r>
+              <a:rPr lang="en-US" sz="1800" b="1" dirty="0">
+                <a:solidFill>
+                  <a:schemeClr val="tx2"/>
+                </a:solidFill>
+              </a:rPr>
+              <a:t>What the prototype proves</a:t>
+            </a:r>
+            <a:endParaRPr lang="en-US" sz="1800" dirty="0"/>
+          </a:p>
+        </p:txBody>
+      </p:sp>
+      <p:sp>
+        <p:nvSpPr>
+          <p:cNvPr id="5" name="Lane 1 body"/>
+          <p:cNvSpPr txBox="1"/>
+          <p:nvPr/>
+        </p:nvSpPr>
+        <p:spPr>
+          <a:xfrm>
+            <a:off x="777240" y="2057400"/>
+            <a:ext cx="3072384" cy="2651760"/>
+          </a:xfrm>
+          <a:prstGeom prst="rect">
+            <a:avLst/>
+          </a:prstGeom>
+          <a:noFill/>
+          <a:ln/>
+        </p:spPr>
+        <p:txBody>
+          <a:bodyPr wrap="square" lIns="0" tIns="0" rIns="0" bIns="0" rtlCol="0" anchor="t"/>
+          <a:lstStyle/>
+          <a:p>
+            <a:pPr marL="342900" indent="-342900">
+              <a:spcAft>
+                <a:spcPts val="1000"/>
+              </a:spcAft>
+              <a:buSzPct val="100000"/>
+              <a:buChar char="•"/>
+            </a:pPr>
+            <a:r>
+              <a:rPr lang="en-US" sz="1400" dirty="0">
+                <a:solidFill>
+                  <a:schemeClr val="tx2"/>
+                </a:solidFill>
+              </a:rPr>
+              <a:t>SOQL over REST, signed by the CLI session; no stored credentials</a:t>
+            </a:r>
+            <a:endParaRPr lang="en-US" sz="1400" dirty="0"/>
+          </a:p>
+          <a:p>
+            <a:pPr marL="342900" indent="-342900">
+              <a:spcAft>
+                <a:spcPts val="1000"/>
+              </a:spcAft>
+              <a:buSzPct val="100000"/>
+              <a:buChar char="•"/>
+            </a:pPr>
+            <a:r>
+              <a:rPr lang="en-US" sz="1400" dirty="0">
+                <a:solidFill>
+                  <a:schemeClr val="tx2"/>
+                </a:solidFill>
+              </a:rPr>
+              <a:t>Opportunity as the case; Tasks join on WhatId, Leads on ConvertedOpportunityId</a:t>
+            </a:r>
+            <a:endParaRPr lang="en-US" sz="1400" dirty="0"/>
+          </a:p>
+          <a:p>
+            <a:pPr marL="342900" indent="-342900">
+              <a:spcAft>
+                <a:spcPts val="1000"/>
+              </a:spcAft>
+              <a:buSzPct val="100000"/>
+              <a:buChar char="•"/>
+            </a:pPr>
+            <a:r>
+              <a:rPr lang="en-US" sz="1400" dirty="0">
+                <a:solidFill>
+                  <a:schemeClr val="tx2"/>
+                </a:solidFill>
+              </a:rPr>
+              <a:t>History rows collapse to real stage changes; paginated queries</a:t>
+            </a:r>
+            <a:endParaRPr lang="en-US" sz="1400" dirty="0"/>
+          </a:p>
+          <a:p>
+            <a:pPr marL="342900" indent="-342900">
+              <a:spcAft>
+                <a:spcPts val="1000"/>
+              </a:spcAft>
+              <a:buSzPct val="100000"/>
+              <a:buChar char="•"/>
+            </a:pPr>
+            <a:r>
+              <a:rPr lang="en-US" sz="1400" dirty="0">
+                <a:solidFill>
+                  <a:schemeClr val="tx2"/>
+                </a:solidFill>
+              </a:rPr>
+              <a:t>CSV and XES export with start and complete events</a:t>
+            </a:r>
+            <a:endParaRPr lang="en-US" sz="1400" dirty="0"/>
+          </a:p>
+        </p:txBody>
+      </p:sp>
+      <p:sp>
+        <p:nvSpPr>
+          <p:cNvPr id="6" name="Lane 2 card"/>
+          <p:cNvSpPr/>
+          <p:nvPr/>
+        </p:nvSpPr>
+        <p:spPr>
+          <a:xfrm>
+            <a:off x="4315968" y="1325880"/>
+            <a:ext cx="3529584" cy="3520440"/>
+          </a:xfrm>
+          <a:prstGeom prst="roundRect">
+            <a:avLst>
+              <a:gd name="adj" fmla="val 3117"/>
+            </a:avLst>
+          </a:prstGeom>
+          <a:solidFill>
+            <a:srgbClr val="FFEEDD"/>
+          </a:solidFill>
+          <a:ln/>
+        </p:spPr>
+      </p:sp>
+      <p:sp>
+        <p:nvSpPr>
+          <p:cNvPr id="7" name="Lane 2 heading"/>
+          <p:cNvSpPr txBox="1"/>
+          <p:nvPr/>
+        </p:nvSpPr>
+        <p:spPr>
+          <a:xfrm>
+            <a:off x="4544568" y="1508760"/>
+            <a:ext cx="3072384" cy="411480"/>
+          </a:xfrm>
+          <a:prstGeom prst="rect">
+            <a:avLst/>
+          </a:prstGeom>
+          <a:noFill/>
+          <a:ln/>
+        </p:spPr>
+        <p:txBody>
+          <a:bodyPr wrap="square" lIns="0" tIns="0" rIns="0" bIns="0" rtlCol="0" anchor="t"/>
+          <a:lstStyle/>
+          <a:p>
+            <a:pPr indent="0" marL="0">
+              <a:buNone/>
+            </a:pPr>
+            <a:r>
+              <a:rPr lang="en-US" sz="1800" b="1" dirty="0">
+                <a:solidFill>
+                  <a:schemeClr val="tx2"/>
+                </a:solidFill>
+              </a:rPr>
+              <a:t>Known limits</a:t>
+            </a:r>
+            <a:endParaRPr lang="en-US" sz="1800" dirty="0"/>
+          </a:p>
+        </p:txBody>
+      </p:sp>
+      <p:sp>
+        <p:nvSpPr>
+          <p:cNvPr id="8" name="Lane 2 body"/>
+          <p:cNvSpPr txBox="1"/>
+          <p:nvPr/>
+        </p:nvSpPr>
+        <p:spPr>
+          <a:xfrm>
+            <a:off x="4544568" y="2057400"/>
+            <a:ext cx="3072384" cy="2651760"/>
+          </a:xfrm>
+          <a:prstGeom prst="rect">
+            <a:avLst/>
+          </a:prstGeom>
+          <a:noFill/>
+          <a:ln/>
+        </p:spPr>
+        <p:txBody>
+          <a:bodyPr wrap="square" lIns="0" tIns="0" rIns="0" bIns="0" rtlCol="0" anchor="t"/>
+          <a:lstStyle/>
+          <a:p>
+            <a:pPr marL="342900" indent="-342900">
+              <a:spcAft>
+                <a:spcPts val="1000"/>
+              </a:spcAft>
+              <a:buSzPct val="100000"/>
+              <a:buChar char="•"/>
+            </a:pPr>
+            <a:r>
+              <a:rPr lang="en-US" sz="1400" dirty="0">
+                <a:solidFill>
+                  <a:schemeClr val="tx2"/>
+                </a:solidFill>
+              </a:rPr>
+              <a:t>Task created → completed can include queueing time</a:t>
+            </a:r>
+            <a:endParaRPr lang="en-US" sz="1400" dirty="0"/>
+          </a:p>
+          <a:p>
+            <a:pPr marL="342900" indent="-342900">
+              <a:spcAft>
+                <a:spcPts val="1000"/>
+              </a:spcAft>
+              <a:buSzPct val="100000"/>
+              <a:buChar char="•"/>
+            </a:pPr>
+            <a:r>
+              <a:rPr lang="en-US" sz="1400" dirty="0">
+                <a:solidFill>
+                  <a:schemeClr val="tx2"/>
+                </a:solidFill>
+              </a:rPr>
+              <a:t>Open tasks have no completion time yet</a:t>
+            </a:r>
+            <a:endParaRPr lang="en-US" sz="1400" dirty="0"/>
+          </a:p>
+          <a:p>
+            <a:pPr marL="342900" indent="-342900">
+              <a:spcAft>
+                <a:spcPts val="1000"/>
+              </a:spcAft>
+              <a:buSzPct val="100000"/>
+              <a:buChar char="•"/>
+            </a:pPr>
+            <a:r>
+              <a:rPr lang="en-US" sz="1400" dirty="0">
+                <a:solidFill>
+                  <a:schemeClr val="tx2"/>
+                </a:solidFill>
+              </a:rPr>
+              <a:t>Trial orgs can't backdate history, so the analysis uses simulated data</a:t>
+            </a:r>
+            <a:endParaRPr lang="en-US" sz="1400" dirty="0"/>
+          </a:p>
+          <a:p>
+            <a:pPr marL="342900" indent="-342900">
+              <a:spcAft>
+                <a:spcPts val="1000"/>
+              </a:spcAft>
+              <a:buSzPct val="100000"/>
+              <a:buChar char="•"/>
+            </a:pPr>
+            <a:r>
+              <a:rPr lang="en-US" sz="1400" dirty="0">
+                <a:solidFill>
+                  <a:schemeClr val="tx2"/>
+                </a:solidFill>
+              </a:rPr>
+              <a:t>Import into a process mining tool still to verify</a:t>
+            </a:r>
+            <a:endParaRPr lang="en-US" sz="1400" dirty="0"/>
+          </a:p>
+        </p:txBody>
+      </p:sp>
+      <p:sp>
+        <p:nvSpPr>
+          <p:cNvPr id="9" name="Lane 3 card"/>
+          <p:cNvSpPr/>
+          <p:nvPr/>
+        </p:nvSpPr>
+        <p:spPr>
+          <a:xfrm>
+            <a:off x="8083296" y="1325880"/>
+            <a:ext cx="3529584" cy="3520440"/>
+          </a:xfrm>
+          <a:prstGeom prst="roundRect">
+            <a:avLst>
+              <a:gd name="adj" fmla="val 3117"/>
+            </a:avLst>
+          </a:prstGeom>
+          <a:solidFill>
+            <a:schemeClr val="tx2"/>
+          </a:solidFill>
+          <a:ln/>
+        </p:spPr>
+      </p:sp>
+      <p:sp>
+        <p:nvSpPr>
+          <p:cNvPr id="10" name="Lane 3 heading"/>
+          <p:cNvSpPr txBox="1"/>
+          <p:nvPr/>
+        </p:nvSpPr>
+        <p:spPr>
+          <a:xfrm>
+            <a:off x="8311896" y="1508760"/>
+            <a:ext cx="3072384" cy="411480"/>
+          </a:xfrm>
+          <a:prstGeom prst="rect">
+            <a:avLst/>
+          </a:prstGeom>
+          <a:noFill/>
+          <a:ln/>
+        </p:spPr>
+        <p:txBody>
+          <a:bodyPr wrap="square" lIns="0" tIns="0" rIns="0" bIns="0" rtlCol="0" anchor="t"/>
+          <a:lstStyle/>
+          <a:p>
+            <a:pPr indent="0" marL="0">
+              <a:buNone/>
+            </a:pPr>
+            <a:r>
+              <a:rPr lang="en-US" sz="1800" b="1" dirty="0">
+                <a:solidFill>
+                  <a:schemeClr val="bg1"/>
+                </a:solidFill>
+              </a:rPr>
+              <a:t>Production path</a:t>
+            </a:r>
+            <a:endParaRPr lang="en-US" sz="1800" dirty="0"/>
+          </a:p>
+        </p:txBody>
+      </p:sp>
+      <p:sp>
+        <p:nvSpPr>
+          <p:cNvPr id="11" name="Lane 3 body"/>
+          <p:cNvSpPr txBox="1"/>
+          <p:nvPr/>
+        </p:nvSpPr>
+        <p:spPr>
+          <a:xfrm>
+            <a:off x="8311896" y="2057400"/>
+            <a:ext cx="3072384" cy="2651760"/>
+          </a:xfrm>
+          <a:prstGeom prst="rect">
+            <a:avLst/>
+          </a:prstGeom>
+          <a:noFill/>
+          <a:ln/>
+        </p:spPr>
+        <p:txBody>
+          <a:bodyPr wrap="square" lIns="0" tIns="0" rIns="0" bIns="0" rtlCol="0" anchor="t"/>
+          <a:lstStyle/>
+          <a:p>
+            <a:pPr marL="342900" indent="-342900">
+              <a:spcAft>
+                <a:spcPts val="1000"/>
+              </a:spcAft>
+              <a:buSzPct val="100000"/>
+              <a:buChar char="•"/>
+            </a:pPr>
+            <a:r>
+              <a:rPr lang="en-US" sz="1400" dirty="0">
+                <a:solidFill>
+                  <a:schemeClr val="bg1"/>
+                </a:solidFill>
+              </a:rPr>
+              <a:t>Bulk API 2.0 with incremental refresh on SystemModstamp</a:t>
+            </a:r>
+            <a:endParaRPr lang="en-US" sz="1400" dirty="0"/>
+          </a:p>
+          <a:p>
+            <a:pPr marL="342900" indent="-342900">
+              <a:spcAft>
+                <a:spcPts val="1000"/>
+              </a:spcAft>
+              <a:buSzPct val="100000"/>
+              <a:buChar char="•"/>
+            </a:pPr>
+            <a:r>
+              <a:rPr lang="en-US" sz="1400" dirty="0">
+                <a:solidFill>
+                  <a:schemeClr val="bg1"/>
+                </a:solidFill>
+              </a:rPr>
+              <a:t>Stable event IDs and deterministic ordering for timestamp ties</a:t>
+            </a:r>
+            <a:endParaRPr lang="en-US" sz="1400" dirty="0"/>
+          </a:p>
+          <a:p>
+            <a:pPr marL="342900" indent="-342900">
+              <a:spcAft>
+                <a:spcPts val="1000"/>
+              </a:spcAft>
+              <a:buSzPct val="100000"/>
+              <a:buChar char="•"/>
+            </a:pPr>
+            <a:r>
+              <a:rPr lang="en-US" sz="1400" dirty="0">
+                <a:solidFill>
+                  <a:schemeClr val="bg1"/>
+                </a:solidFill>
+              </a:rPr>
+              <a:t>Approval history from ProcessInstance and its steps</a:t>
+            </a:r>
+            <a:endParaRPr lang="en-US" sz="1400" dirty="0"/>
+          </a:p>
+          <a:p>
+            <a:pPr marL="342900" indent="-342900">
+              <a:spcAft>
+                <a:spcPts val="1000"/>
+              </a:spcAft>
+              <a:buSzPct val="100000"/>
+              <a:buChar char="•"/>
+            </a:pPr>
+            <a:r>
+              <a:rPr lang="en-US" sz="1400" dirty="0">
+                <a:solidFill>
+                  <a:schemeClr val="bg1"/>
+                </a:solidFill>
+              </a:rPr>
+              <a:t>Reconciliation and data-quality checks against source counts</a:t>
+            </a:r>
+            <a:endParaRPr lang="en-US" sz="1400" dirty="0"/>
+          </a:p>
+        </p:txBody>
+      </p:sp>
+      <p:sp>
+        <p:nvSpPr>
+          <p:cNvPr id="12" name="Production takeaway"/>
+          <p:cNvSpPr txBox="1"/>
+          <p:nvPr/>
+        </p:nvSpPr>
+        <p:spPr>
+          <a:xfrm>
+            <a:off x="548640" y="5120640"/>
+            <a:ext cx="11064240" cy="457200"/>
+          </a:xfrm>
+          <a:prstGeom prst="rect">
+            <a:avLst/>
+          </a:prstGeom>
+          <a:noFill/>
+          <a:ln/>
+        </p:spPr>
+        <p:txBody>
+          <a:bodyPr wrap="square" lIns="0" tIns="0" rIns="0" bIns="0" rtlCol="0" anchor="t"/>
+          <a:lstStyle/>
+          <a:p>
+            <a:pPr indent="0" marL="0">
+              <a:buNone/>
+            </a:pPr>
+            <a:r>
+              <a:rPr lang="en-US" sz="1800" i="1" dirty="0">
+                <a:solidFill>
+                  <a:schemeClr val="accent6"/>
+                </a:solidFill>
+              </a:rPr>
+              <a:t>The plumbing is proven. What's left is event semantics and data quality, not connectivity.</a:t>
+            </a:r>
+            <a:endParaRPr lang="en-US" sz="1800" dirty="0"/>
+          </a:p>
+        </p:txBody>
+      </p:sp>
+      <p:sp>
+        <p:nvSpPr>
+          <p:cNvPr id="25" name="Slide Number Placeholder 0"/>
+          <p:cNvSpPr>
+            <a:spLocks noGrp="1"/>
+          </p:cNvSpPr>
+          <p:nvPr>
+            <p:ph type="sldNum" sz="quarter" idx="4294967295"/>
+          </p:nvPr>
+        </p:nvSpPr>
+        <p:spPr>
+          <a:xfrm>
+            <a:off x="11155680" y="6400800"/>
+            <a:ext cx="457200" cy="274320"/>
+          </a:xfrm>
+          <a:prstGeom prst="rect">
+            <a:avLst/>
+          </a:prstGeom>
+          <a:extLst>
+            <a:ext uri="{C572A759-6A51-4108-AA02-DFA0A04FC94B}">
+              <ma14:wrappingTextBoxFlag xmlns:ma14="http://schemas.microsoft.com/office/mac/drawingml/2011/main" val="0"/>
+            </a:ext>
+          </a:extLst>
+        </p:spPr>
+        <p:txBody>
+          <a:bodyPr/>
+          <a:lstStyle>
+            <a:lvl1pPr>
+              <a:defRPr sz="1000">
+                <a:solidFill>
+                  <a:schemeClr val="accent6"/>
+                </a:solidFill>
+              </a:defRPr>
+            </a:lvl1pPr>
+          </a:lstStyle>
+          <a:p>
+            <a:pPr algn="r"/>
+            <a:fld id="{F7021451-1387-4CA6-816F-3879F97B5CBC}" type="slidenum">
+              <a:rPr b="0" lang="en-US"/>
+              <a:t>3</a:t>
+            </a:fld>
+            <a:endParaRPr lang="en-US"/>
+          </a:p>
+        </p:txBody>
+      </p:sp>
+    </p:spTree>
+  </p:cSld>
+  <p:clrMapOvr>
+    <a:masterClrMapping/>
+  </p:clrMapOvr>
+</p:sld>
+</file>
+
+<file path=ppt/slides/slide4.xml><?xml version="1.0" encoding="utf-8"?>
+<p:sld xmlns:a="http://schemas.openxmlformats.org/drawingml/2006/main" xmlns:r="http://schemas.openxmlformats.org/officeDocument/2006/relationships" xmlns:p="http://schemas.openxmlformats.org/presentationml/2006/main">
+  <p:cSld name="Slide 4">
+    <p:spTree>
+      <p:nvGrpSpPr>
+        <p:cNvPr id="1" name=""/>
+        <p:cNvGrpSpPr/>
+        <p:nvPr/>
+      </p:nvGrpSpPr>
+      <p:grpSpPr>
+        <a:xfrm>
+          <a:off x="0" y="0"/>
+          <a:ext cx="0" cy="0"/>
+          <a:chOff x="0" y="0"/>
+          <a:chExt cx="0" cy="0"/>
+        </a:xfrm>
+      </p:grpSpPr>
+      <p:sp>
+        <p:nvSpPr>
+          <p:cNvPr id="2" name="Text 0"/>
+          <p:cNvSpPr/>
+          <p:nvPr>
+            <p:ph idx="100" type="title" hasCustomPrompt="1"/>
+          </p:nvPr>
+        </p:nvSpPr>
+        <p:spPr>
+          <a:xfrm>
+            <a:off x="548640" y="320040"/>
+            <a:ext cx="11064240" cy="822960"/>
+          </a:xfrm>
+          <a:prstGeom prst="rect">
+            <a:avLst/>
+          </a:prstGeom>
+          <a:noFill/>
+          <a:ln/>
+        </p:spPr>
+        <p:txBody>
+          <a:bodyPr wrap="square" lIns="0" tIns="0" rIns="0" bIns="0" rtlCol="0" anchor="ctr"/>
+          <a:lstStyle/>
+          <a:p>
+            <a:pPr algn="l" indent="0" marL="0">
+              <a:buNone/>
+            </a:pPr>
+            <a:r>
+              <a:rPr lang="en-US" sz="3000" b="1" dirty="0">
+                <a:solidFill>
+                  <a:schemeClr val="tx2"/>
+                </a:solidFill>
+              </a:rPr>
               <a:t>Hosted demo, live extraction proof and source code</a:t>
             </a:r>
             <a:endParaRPr lang="en-US" sz="3000" dirty="0"/>
@@ -4026,7 +4716,7 @@
                   <a:schemeClr val="tx2"/>
                 </a:solidFill>
               </a:rPr>
-              <a:t>Live Salesforce run and downloads</a:t>
+              <a:t>Data assets and downloads</a:t>
             </a:r>
             <a:endParaRPr lang="en-US" sz="1600" dirty="0"/>
           </a:p>
@@ -4240,8 +4930,8 @@
         </p:nvSpPr>
         <p:spPr>
           <a:xfrm>
-            <a:off x="6903720" y="1371600"/>
-            <a:ext cx="4802925" cy="4434840"/>
+            <a:off x="6903720" y="1735360"/>
+            <a:ext cx="4754880" cy="3734752"/>
           </a:xfrm>
           <a:prstGeom prst="rect">
             <a:avLst/>
@@ -4259,7 +4949,7 @@
       </p:sp>
       <p:pic>
         <p:nvPicPr>
-          <p:cNvPr id="29" name="Value case screenshot" descr="Value case one-pager on the hosted site">    </p:cNvPr>
+          <p:cNvPr id="29" name="Overview screenshot" descr="Overview page of the hosted site">    </p:cNvPr>
           <p:cNvPicPr>
             <a:picLocks noChangeAspect="1"/>
           </p:cNvPicPr>
@@ -4273,8 +4963,8 @@
         </p:blipFill>
         <p:spPr>
           <a:xfrm>
-            <a:off x="6949440" y="1417320"/>
-            <a:ext cx="4711485" cy="4343400"/>
+            <a:off x="6949440" y="1781080"/>
+            <a:ext cx="4663440" cy="3643312"/>
           </a:xfrm>
           <a:prstGeom prst="rect">
             <a:avLst/>
@@ -4320,7 +5010,7 @@
             <a:pPr algn="r"/>
             <a:fld id="{F7021451-1387-4CA6-816F-3879F97B5CBC}" type="slidenum">
               <a:rPr b="0" lang="en-US"/>
-              <a:t>3</a:t>
+              <a:t>4</a:t>
             </a:fld>
             <a:endParaRPr lang="en-US"/>
           </a:p>

</xml_diff>

<commit_message>
Tech deck: drop the prototype-to-production slide
Co-Authored-By: Claude Opus 5.5 <noreply@anthropic.com>
</commit_message>
<xml_diff>
--- a/deck/salesforce-process-intelligence-tech-setup.pptx
+++ b/deck/salesforce-process-intelligence-tech-setup.pptx
@@ -8,10 +8,9 @@
     <p:sldId id="256" r:id="rId2"/>
     <p:sldId id="257" r:id="rId3"/>
     <p:sldId id="258" r:id="rId4"/>
-    <p:sldId id="259" r:id="rId5"/>
   </p:sldIdLst>
   <p:notesMasterIdLst>
-    <p:notesMasterId r:id="rId6"/>
+    <p:notesMasterId r:id="rId5"/>
   </p:notesMasterIdLst>
   <p:sldSz cx="12192000" cy="6858000"/>
   <p:notesSz cx="6858000" cy="12192000"/>
@@ -110,12 +109,11 @@
   <p:extLst>
     <p:ext uri="{521415D9-36F7-43E2-AB2F-B90AF26B5E84}">
       <p14:sectionLst xmlns:p14="http://schemas.microsoft.com/office/powerpoint/2010/main">
-        <p14:section name="Tech setup" id="{9a267680-d26b-ca61-99bb-a9964de8cc4d}">
+        <p14:section name="Tech setup" id="{4fdea6c2-f935-2ca6-1ebd-0ecd4283696d}">
           <p14:sldIdLst>
             <p14:sldId id="256"/>
             <p14:sldId id="257"/>
             <p14:sldId id="258"/>
-            <p14:sldId id="259"/>
           </p14:sldIdLst>
         </p14:section>
       </p14:sectionLst>
@@ -698,7 +696,7 @@
           <a:p>
             <a:r>
               <a:rPr lang="en-US" dirty="0"/>
-              <a:t>The prototype proves the extraction and event-log design end to end on a real org. The limits are about event semantics and data, not plumbing. Production work is incremental refresh at volume, stable identifiers, approval history from the approval objects, and reconciliation so Finance can trust the numbers.</a:t>
+              <a:t>All of this is hosted. The overview carries the value items and business case; Data assets has the live run and every event log; the repo has the pipeline, the seeding script and the README with the setup gotchas from a new trial org.</a:t>
             </a:r>
             <a:endParaRPr lang="en-US" dirty="0"/>
           </a:p>
@@ -722,94 +720,6 @@
             <a:fld id="{F7021451-1387-4CA6-816F-3879F97B5CBC}" type="slidenum">
               <a:rPr lang="en-US"/>
               <a:t>3</a:t>
-            </a:fld>
-            <a:endParaRPr lang="en-US"/>
-          </a:p>
-        </p:txBody>
-      </p:sp>
-    </p:spTree>
-    <p:extLst>
-      <p:ext uri="{BB962C8B-B14F-4D97-AF65-F5344CB8AC3E}">
-        <p14:creationId xmlns:p14="http://schemas.microsoft.com/office/powerpoint/2010/main" val="1024086991"/>
-      </p:ext>
-    </p:extLst>
-  </p:cSld>
-  <p:clrMapOvr>
-    <a:masterClrMapping/>
-  </p:clrMapOvr>
-</p:notes>
-</file>
-
-<file path=ppt/notesSlides/notesSlide4.xml><?xml version="1.0" encoding="utf-8"?>
-<p:notes xmlns:a="http://schemas.openxmlformats.org/drawingml/2006/main" xmlns:r="http://schemas.openxmlformats.org/officeDocument/2006/relationships" xmlns:p="http://schemas.openxmlformats.org/presentationml/2006/main">
-  <p:cSld>
-    <p:spTree>
-      <p:nvGrpSpPr>
-        <p:cNvPr id="1" name=""/>
-        <p:cNvGrpSpPr/>
-        <p:nvPr/>
-      </p:nvGrpSpPr>
-      <p:grpSpPr>
-        <a:xfrm>
-          <a:off x="0" y="0"/>
-          <a:ext cx="0" cy="0"/>
-          <a:chOff x="0" y="0"/>
-          <a:chExt cx="0" cy="0"/>
-        </a:xfrm>
-      </p:grpSpPr>
-      <p:sp>
-        <p:nvSpPr>
-          <p:cNvPr id="2" name="Slide Image Placeholder 1"/>
-          <p:cNvSpPr>
-            <a:spLocks noGrp="1" noRot="1" noChangeAspect="1"/>
-          </p:cNvSpPr>
-          <p:nvPr>
-            <p:ph type="sldImg"/>
-          </p:nvPr>
-        </p:nvSpPr>
-        <p:spPr/>
-      </p:sp>
-      <p:sp>
-        <p:nvSpPr>
-          <p:cNvPr id="3" name="Notes Placeholder 2"/>
-          <p:cNvSpPr>
-            <a:spLocks noGrp="1"/>
-          </p:cNvSpPr>
-          <p:nvPr>
-            <p:ph type="body" idx="1"/>
-          </p:nvPr>
-        </p:nvSpPr>
-        <p:spPr/>
-        <p:txBody>
-          <a:bodyPr/>
-          <a:lstStyle/>
-          <a:p>
-            <a:r>
-              <a:rPr lang="en-US" dirty="0"/>
-              <a:t>All of this is hosted. The overview carries the value items and business case; Data assets has the live run and every event log; the repo has the pipeline, the seeding script and the README with the setup gotchas from a new trial org.</a:t>
-            </a:r>
-            <a:endParaRPr lang="en-US" dirty="0"/>
-          </a:p>
-        </p:txBody>
-      </p:sp>
-      <p:sp>
-        <p:nvSpPr>
-          <p:cNvPr id="4" name="Slide Number Placeholder 3"/>
-          <p:cNvSpPr>
-            <a:spLocks noGrp="1"/>
-          </p:cNvSpPr>
-          <p:nvPr>
-            <p:ph type="sldNum" sz="quarter" idx="10"/>
-          </p:nvPr>
-        </p:nvSpPr>
-        <p:spPr/>
-        <p:txBody>
-          <a:bodyPr/>
-          <a:lstStyle/>
-          <a:p>
-            <a:fld id="{F7021451-1387-4CA6-816F-3879F97B5CBC}" type="slidenum">
-              <a:rPr lang="en-US"/>
-              <a:t>4</a:t>
             </a:fld>
             <a:endParaRPr lang="en-US"/>
           </a:p>
@@ -3531,606 +3441,6 @@
                   <a:schemeClr val="tx2"/>
                 </a:solidFill>
               </a:rPr>
-              <a:t>Prototype today, production next</a:t>
-            </a:r>
-            <a:endParaRPr lang="en-US" sz="3000" dirty="0"/>
-          </a:p>
-        </p:txBody>
-      </p:sp>
-      <p:sp>
-        <p:nvSpPr>
-          <p:cNvPr id="3" name="Lane 1 card"/>
-          <p:cNvSpPr/>
-          <p:nvPr/>
-        </p:nvSpPr>
-        <p:spPr>
-          <a:xfrm>
-            <a:off x="548640" y="1325880"/>
-            <a:ext cx="3529584" cy="3520440"/>
-          </a:xfrm>
-          <a:prstGeom prst="roundRect">
-            <a:avLst>
-              <a:gd name="adj" fmla="val 3117"/>
-            </a:avLst>
-          </a:prstGeom>
-          <a:solidFill>
-            <a:schemeClr val="bg2"/>
-          </a:solidFill>
-          <a:ln/>
-        </p:spPr>
-      </p:sp>
-      <p:sp>
-        <p:nvSpPr>
-          <p:cNvPr id="4" name="Lane 1 heading"/>
-          <p:cNvSpPr txBox="1"/>
-          <p:nvPr/>
-        </p:nvSpPr>
-        <p:spPr>
-          <a:xfrm>
-            <a:off x="777240" y="1508760"/>
-            <a:ext cx="3072384" cy="411480"/>
-          </a:xfrm>
-          <a:prstGeom prst="rect">
-            <a:avLst/>
-          </a:prstGeom>
-          <a:noFill/>
-          <a:ln/>
-        </p:spPr>
-        <p:txBody>
-          <a:bodyPr wrap="square" lIns="0" tIns="0" rIns="0" bIns="0" rtlCol="0" anchor="t"/>
-          <a:lstStyle/>
-          <a:p>
-            <a:pPr indent="0" marL="0">
-              <a:buNone/>
-            </a:pPr>
-            <a:r>
-              <a:rPr lang="en-US" sz="1800" b="1" dirty="0">
-                <a:solidFill>
-                  <a:schemeClr val="tx2"/>
-                </a:solidFill>
-              </a:rPr>
-              <a:t>What the prototype proves</a:t>
-            </a:r>
-            <a:endParaRPr lang="en-US" sz="1800" dirty="0"/>
-          </a:p>
-        </p:txBody>
-      </p:sp>
-      <p:sp>
-        <p:nvSpPr>
-          <p:cNvPr id="5" name="Lane 1 body"/>
-          <p:cNvSpPr txBox="1"/>
-          <p:nvPr/>
-        </p:nvSpPr>
-        <p:spPr>
-          <a:xfrm>
-            <a:off x="777240" y="2057400"/>
-            <a:ext cx="3072384" cy="2651760"/>
-          </a:xfrm>
-          <a:prstGeom prst="rect">
-            <a:avLst/>
-          </a:prstGeom>
-          <a:noFill/>
-          <a:ln/>
-        </p:spPr>
-        <p:txBody>
-          <a:bodyPr wrap="square" lIns="0" tIns="0" rIns="0" bIns="0" rtlCol="0" anchor="t"/>
-          <a:lstStyle/>
-          <a:p>
-            <a:pPr marL="342900" indent="-342900">
-              <a:spcAft>
-                <a:spcPts val="1000"/>
-              </a:spcAft>
-              <a:buSzPct val="100000"/>
-              <a:buChar char="•"/>
-            </a:pPr>
-            <a:r>
-              <a:rPr lang="en-US" sz="1400" dirty="0">
-                <a:solidFill>
-                  <a:schemeClr val="tx2"/>
-                </a:solidFill>
-              </a:rPr>
-              <a:t>SOQL over REST, signed by the CLI session; no stored credentials</a:t>
-            </a:r>
-            <a:endParaRPr lang="en-US" sz="1400" dirty="0"/>
-          </a:p>
-          <a:p>
-            <a:pPr marL="342900" indent="-342900">
-              <a:spcAft>
-                <a:spcPts val="1000"/>
-              </a:spcAft>
-              <a:buSzPct val="100000"/>
-              <a:buChar char="•"/>
-            </a:pPr>
-            <a:r>
-              <a:rPr lang="en-US" sz="1400" dirty="0">
-                <a:solidFill>
-                  <a:schemeClr val="tx2"/>
-                </a:solidFill>
-              </a:rPr>
-              <a:t>Opportunity as the case; Tasks join on WhatId, Leads on ConvertedOpportunityId</a:t>
-            </a:r>
-            <a:endParaRPr lang="en-US" sz="1400" dirty="0"/>
-          </a:p>
-          <a:p>
-            <a:pPr marL="342900" indent="-342900">
-              <a:spcAft>
-                <a:spcPts val="1000"/>
-              </a:spcAft>
-              <a:buSzPct val="100000"/>
-              <a:buChar char="•"/>
-            </a:pPr>
-            <a:r>
-              <a:rPr lang="en-US" sz="1400" dirty="0">
-                <a:solidFill>
-                  <a:schemeClr val="tx2"/>
-                </a:solidFill>
-              </a:rPr>
-              <a:t>History rows collapse to real stage changes; paginated queries</a:t>
-            </a:r>
-            <a:endParaRPr lang="en-US" sz="1400" dirty="0"/>
-          </a:p>
-          <a:p>
-            <a:pPr marL="342900" indent="-342900">
-              <a:spcAft>
-                <a:spcPts val="1000"/>
-              </a:spcAft>
-              <a:buSzPct val="100000"/>
-              <a:buChar char="•"/>
-            </a:pPr>
-            <a:r>
-              <a:rPr lang="en-US" sz="1400" dirty="0">
-                <a:solidFill>
-                  <a:schemeClr val="tx2"/>
-                </a:solidFill>
-              </a:rPr>
-              <a:t>CSV and XES export with start and complete events</a:t>
-            </a:r>
-            <a:endParaRPr lang="en-US" sz="1400" dirty="0"/>
-          </a:p>
-        </p:txBody>
-      </p:sp>
-      <p:sp>
-        <p:nvSpPr>
-          <p:cNvPr id="6" name="Lane 2 card"/>
-          <p:cNvSpPr/>
-          <p:nvPr/>
-        </p:nvSpPr>
-        <p:spPr>
-          <a:xfrm>
-            <a:off x="4315968" y="1325880"/>
-            <a:ext cx="3529584" cy="3520440"/>
-          </a:xfrm>
-          <a:prstGeom prst="roundRect">
-            <a:avLst>
-              <a:gd name="adj" fmla="val 3117"/>
-            </a:avLst>
-          </a:prstGeom>
-          <a:solidFill>
-            <a:srgbClr val="FFEEDD"/>
-          </a:solidFill>
-          <a:ln/>
-        </p:spPr>
-      </p:sp>
-      <p:sp>
-        <p:nvSpPr>
-          <p:cNvPr id="7" name="Lane 2 heading"/>
-          <p:cNvSpPr txBox="1"/>
-          <p:nvPr/>
-        </p:nvSpPr>
-        <p:spPr>
-          <a:xfrm>
-            <a:off x="4544568" y="1508760"/>
-            <a:ext cx="3072384" cy="411480"/>
-          </a:xfrm>
-          <a:prstGeom prst="rect">
-            <a:avLst/>
-          </a:prstGeom>
-          <a:noFill/>
-          <a:ln/>
-        </p:spPr>
-        <p:txBody>
-          <a:bodyPr wrap="square" lIns="0" tIns="0" rIns="0" bIns="0" rtlCol="0" anchor="t"/>
-          <a:lstStyle/>
-          <a:p>
-            <a:pPr indent="0" marL="0">
-              <a:buNone/>
-            </a:pPr>
-            <a:r>
-              <a:rPr lang="en-US" sz="1800" b="1" dirty="0">
-                <a:solidFill>
-                  <a:schemeClr val="tx2"/>
-                </a:solidFill>
-              </a:rPr>
-              <a:t>Known limits</a:t>
-            </a:r>
-            <a:endParaRPr lang="en-US" sz="1800" dirty="0"/>
-          </a:p>
-        </p:txBody>
-      </p:sp>
-      <p:sp>
-        <p:nvSpPr>
-          <p:cNvPr id="8" name="Lane 2 body"/>
-          <p:cNvSpPr txBox="1"/>
-          <p:nvPr/>
-        </p:nvSpPr>
-        <p:spPr>
-          <a:xfrm>
-            <a:off x="4544568" y="2057400"/>
-            <a:ext cx="3072384" cy="2651760"/>
-          </a:xfrm>
-          <a:prstGeom prst="rect">
-            <a:avLst/>
-          </a:prstGeom>
-          <a:noFill/>
-          <a:ln/>
-        </p:spPr>
-        <p:txBody>
-          <a:bodyPr wrap="square" lIns="0" tIns="0" rIns="0" bIns="0" rtlCol="0" anchor="t"/>
-          <a:lstStyle/>
-          <a:p>
-            <a:pPr marL="342900" indent="-342900">
-              <a:spcAft>
-                <a:spcPts val="1000"/>
-              </a:spcAft>
-              <a:buSzPct val="100000"/>
-              <a:buChar char="•"/>
-            </a:pPr>
-            <a:r>
-              <a:rPr lang="en-US" sz="1400" dirty="0">
-                <a:solidFill>
-                  <a:schemeClr val="tx2"/>
-                </a:solidFill>
-              </a:rPr>
-              <a:t>Task created → completed can include queueing time</a:t>
-            </a:r>
-            <a:endParaRPr lang="en-US" sz="1400" dirty="0"/>
-          </a:p>
-          <a:p>
-            <a:pPr marL="342900" indent="-342900">
-              <a:spcAft>
-                <a:spcPts val="1000"/>
-              </a:spcAft>
-              <a:buSzPct val="100000"/>
-              <a:buChar char="•"/>
-            </a:pPr>
-            <a:r>
-              <a:rPr lang="en-US" sz="1400" dirty="0">
-                <a:solidFill>
-                  <a:schemeClr val="tx2"/>
-                </a:solidFill>
-              </a:rPr>
-              <a:t>Open tasks have no completion time yet</a:t>
-            </a:r>
-            <a:endParaRPr lang="en-US" sz="1400" dirty="0"/>
-          </a:p>
-          <a:p>
-            <a:pPr marL="342900" indent="-342900">
-              <a:spcAft>
-                <a:spcPts val="1000"/>
-              </a:spcAft>
-              <a:buSzPct val="100000"/>
-              <a:buChar char="•"/>
-            </a:pPr>
-            <a:r>
-              <a:rPr lang="en-US" sz="1400" dirty="0">
-                <a:solidFill>
-                  <a:schemeClr val="tx2"/>
-                </a:solidFill>
-              </a:rPr>
-              <a:t>Trial orgs can't backdate history, so the analysis uses simulated data</a:t>
-            </a:r>
-            <a:endParaRPr lang="en-US" sz="1400" dirty="0"/>
-          </a:p>
-          <a:p>
-            <a:pPr marL="342900" indent="-342900">
-              <a:spcAft>
-                <a:spcPts val="1000"/>
-              </a:spcAft>
-              <a:buSzPct val="100000"/>
-              <a:buChar char="•"/>
-            </a:pPr>
-            <a:r>
-              <a:rPr lang="en-US" sz="1400" dirty="0">
-                <a:solidFill>
-                  <a:schemeClr val="tx2"/>
-                </a:solidFill>
-              </a:rPr>
-              <a:t>Import into a process mining tool still to verify</a:t>
-            </a:r>
-            <a:endParaRPr lang="en-US" sz="1400" dirty="0"/>
-          </a:p>
-        </p:txBody>
-      </p:sp>
-      <p:sp>
-        <p:nvSpPr>
-          <p:cNvPr id="9" name="Lane 3 card"/>
-          <p:cNvSpPr/>
-          <p:nvPr/>
-        </p:nvSpPr>
-        <p:spPr>
-          <a:xfrm>
-            <a:off x="8083296" y="1325880"/>
-            <a:ext cx="3529584" cy="3520440"/>
-          </a:xfrm>
-          <a:prstGeom prst="roundRect">
-            <a:avLst>
-              <a:gd name="adj" fmla="val 3117"/>
-            </a:avLst>
-          </a:prstGeom>
-          <a:solidFill>
-            <a:schemeClr val="tx2"/>
-          </a:solidFill>
-          <a:ln/>
-        </p:spPr>
-      </p:sp>
-      <p:sp>
-        <p:nvSpPr>
-          <p:cNvPr id="10" name="Lane 3 heading"/>
-          <p:cNvSpPr txBox="1"/>
-          <p:nvPr/>
-        </p:nvSpPr>
-        <p:spPr>
-          <a:xfrm>
-            <a:off x="8311896" y="1508760"/>
-            <a:ext cx="3072384" cy="411480"/>
-          </a:xfrm>
-          <a:prstGeom prst="rect">
-            <a:avLst/>
-          </a:prstGeom>
-          <a:noFill/>
-          <a:ln/>
-        </p:spPr>
-        <p:txBody>
-          <a:bodyPr wrap="square" lIns="0" tIns="0" rIns="0" bIns="0" rtlCol="0" anchor="t"/>
-          <a:lstStyle/>
-          <a:p>
-            <a:pPr indent="0" marL="0">
-              <a:buNone/>
-            </a:pPr>
-            <a:r>
-              <a:rPr lang="en-US" sz="1800" b="1" dirty="0">
-                <a:solidFill>
-                  <a:schemeClr val="bg1"/>
-                </a:solidFill>
-              </a:rPr>
-              <a:t>Production path</a:t>
-            </a:r>
-            <a:endParaRPr lang="en-US" sz="1800" dirty="0"/>
-          </a:p>
-        </p:txBody>
-      </p:sp>
-      <p:sp>
-        <p:nvSpPr>
-          <p:cNvPr id="11" name="Lane 3 body"/>
-          <p:cNvSpPr txBox="1"/>
-          <p:nvPr/>
-        </p:nvSpPr>
-        <p:spPr>
-          <a:xfrm>
-            <a:off x="8311896" y="2057400"/>
-            <a:ext cx="3072384" cy="2651760"/>
-          </a:xfrm>
-          <a:prstGeom prst="rect">
-            <a:avLst/>
-          </a:prstGeom>
-          <a:noFill/>
-          <a:ln/>
-        </p:spPr>
-        <p:txBody>
-          <a:bodyPr wrap="square" lIns="0" tIns="0" rIns="0" bIns="0" rtlCol="0" anchor="t"/>
-          <a:lstStyle/>
-          <a:p>
-            <a:pPr marL="342900" indent="-342900">
-              <a:spcAft>
-                <a:spcPts val="1000"/>
-              </a:spcAft>
-              <a:buSzPct val="100000"/>
-              <a:buChar char="•"/>
-            </a:pPr>
-            <a:r>
-              <a:rPr lang="en-US" sz="1400" dirty="0">
-                <a:solidFill>
-                  <a:schemeClr val="bg1"/>
-                </a:solidFill>
-              </a:rPr>
-              <a:t>Bulk API 2.0 with incremental refresh on SystemModstamp</a:t>
-            </a:r>
-            <a:endParaRPr lang="en-US" sz="1400" dirty="0"/>
-          </a:p>
-          <a:p>
-            <a:pPr marL="342900" indent="-342900">
-              <a:spcAft>
-                <a:spcPts val="1000"/>
-              </a:spcAft>
-              <a:buSzPct val="100000"/>
-              <a:buChar char="•"/>
-            </a:pPr>
-            <a:r>
-              <a:rPr lang="en-US" sz="1400" dirty="0">
-                <a:solidFill>
-                  <a:schemeClr val="bg1"/>
-                </a:solidFill>
-              </a:rPr>
-              <a:t>Stable event IDs and deterministic ordering for timestamp ties</a:t>
-            </a:r>
-            <a:endParaRPr lang="en-US" sz="1400" dirty="0"/>
-          </a:p>
-          <a:p>
-            <a:pPr marL="342900" indent="-342900">
-              <a:spcAft>
-                <a:spcPts val="1000"/>
-              </a:spcAft>
-              <a:buSzPct val="100000"/>
-              <a:buChar char="•"/>
-            </a:pPr>
-            <a:r>
-              <a:rPr lang="en-US" sz="1400" dirty="0">
-                <a:solidFill>
-                  <a:schemeClr val="bg1"/>
-                </a:solidFill>
-              </a:rPr>
-              <a:t>Approval history from ProcessInstance and its steps</a:t>
-            </a:r>
-            <a:endParaRPr lang="en-US" sz="1400" dirty="0"/>
-          </a:p>
-          <a:p>
-            <a:pPr marL="342900" indent="-342900">
-              <a:spcAft>
-                <a:spcPts val="1000"/>
-              </a:spcAft>
-              <a:buSzPct val="100000"/>
-              <a:buChar char="•"/>
-            </a:pPr>
-            <a:r>
-              <a:rPr lang="en-US" sz="1400" dirty="0">
-                <a:solidFill>
-                  <a:schemeClr val="bg1"/>
-                </a:solidFill>
-              </a:rPr>
-              <a:t>Reconciliation and data-quality checks against source counts</a:t>
-            </a:r>
-            <a:endParaRPr lang="en-US" sz="1400" dirty="0"/>
-          </a:p>
-        </p:txBody>
-      </p:sp>
-      <p:sp>
-        <p:nvSpPr>
-          <p:cNvPr id="12" name="Production takeaway"/>
-          <p:cNvSpPr txBox="1"/>
-          <p:nvPr/>
-        </p:nvSpPr>
-        <p:spPr>
-          <a:xfrm>
-            <a:off x="548640" y="5120640"/>
-            <a:ext cx="11064240" cy="457200"/>
-          </a:xfrm>
-          <a:prstGeom prst="rect">
-            <a:avLst/>
-          </a:prstGeom>
-          <a:noFill/>
-          <a:ln/>
-        </p:spPr>
-        <p:txBody>
-          <a:bodyPr wrap="square" lIns="0" tIns="0" rIns="0" bIns="0" rtlCol="0" anchor="t"/>
-          <a:lstStyle/>
-          <a:p>
-            <a:pPr indent="0" marL="0">
-              <a:buNone/>
-            </a:pPr>
-            <a:r>
-              <a:rPr lang="en-US" sz="1800" i="1" dirty="0">
-                <a:solidFill>
-                  <a:schemeClr val="accent6"/>
-                </a:solidFill>
-              </a:rPr>
-              <a:t>The plumbing is proven. What's left is event semantics and data quality, not connectivity.</a:t>
-            </a:r>
-            <a:endParaRPr lang="en-US" sz="1800" dirty="0"/>
-          </a:p>
-        </p:txBody>
-      </p:sp>
-      <p:sp>
-        <p:nvSpPr>
-          <p:cNvPr id="25" name="Slide Number Placeholder 0"/>
-          <p:cNvSpPr>
-            <a:spLocks noGrp="1"/>
-          </p:cNvSpPr>
-          <p:nvPr>
-            <p:ph type="sldNum" sz="quarter" idx="4294967295"/>
-          </p:nvPr>
-        </p:nvSpPr>
-        <p:spPr>
-          <a:xfrm>
-            <a:off x="11155680" y="6400800"/>
-            <a:ext cx="457200" cy="274320"/>
-          </a:xfrm>
-          <a:prstGeom prst="rect">
-            <a:avLst/>
-          </a:prstGeom>
-          <a:extLst>
-            <a:ext uri="{C572A759-6A51-4108-AA02-DFA0A04FC94B}">
-              <ma14:wrappingTextBoxFlag xmlns:ma14="http://schemas.microsoft.com/office/mac/drawingml/2011/main" val="0"/>
-            </a:ext>
-          </a:extLst>
-        </p:spPr>
-        <p:txBody>
-          <a:bodyPr/>
-          <a:lstStyle>
-            <a:lvl1pPr>
-              <a:defRPr sz="1000">
-                <a:solidFill>
-                  <a:schemeClr val="accent6"/>
-                </a:solidFill>
-              </a:defRPr>
-            </a:lvl1pPr>
-          </a:lstStyle>
-          <a:p>
-            <a:pPr algn="r"/>
-            <a:fld id="{F7021451-1387-4CA6-816F-3879F97B5CBC}" type="slidenum">
-              <a:rPr b="0" lang="en-US"/>
-              <a:t>3</a:t>
-            </a:fld>
-            <a:endParaRPr lang="en-US"/>
-          </a:p>
-        </p:txBody>
-      </p:sp>
-    </p:spTree>
-  </p:cSld>
-  <p:clrMapOvr>
-    <a:masterClrMapping/>
-  </p:clrMapOvr>
-</p:sld>
-</file>
-
-<file path=ppt/slides/slide4.xml><?xml version="1.0" encoding="utf-8"?>
-<p:sld xmlns:a="http://schemas.openxmlformats.org/drawingml/2006/main" xmlns:r="http://schemas.openxmlformats.org/officeDocument/2006/relationships" xmlns:p="http://schemas.openxmlformats.org/presentationml/2006/main">
-  <p:cSld name="Slide 4">
-    <p:spTree>
-      <p:nvGrpSpPr>
-        <p:cNvPr id="1" name=""/>
-        <p:cNvGrpSpPr/>
-        <p:nvPr/>
-      </p:nvGrpSpPr>
-      <p:grpSpPr>
-        <a:xfrm>
-          <a:off x="0" y="0"/>
-          <a:ext cx="0" cy="0"/>
-          <a:chOff x="0" y="0"/>
-          <a:chExt cx="0" cy="0"/>
-        </a:xfrm>
-      </p:grpSpPr>
-      <p:sp>
-        <p:nvSpPr>
-          <p:cNvPr id="2" name="Text 0"/>
-          <p:cNvSpPr/>
-          <p:nvPr>
-            <p:ph idx="100" type="title" hasCustomPrompt="1"/>
-          </p:nvPr>
-        </p:nvSpPr>
-        <p:spPr>
-          <a:xfrm>
-            <a:off x="548640" y="320040"/>
-            <a:ext cx="11064240" cy="822960"/>
-          </a:xfrm>
-          <a:prstGeom prst="rect">
-            <a:avLst/>
-          </a:prstGeom>
-          <a:noFill/>
-          <a:ln/>
-        </p:spPr>
-        <p:txBody>
-          <a:bodyPr wrap="square" lIns="0" tIns="0" rIns="0" bIns="0" rtlCol="0" anchor="ctr"/>
-          <a:lstStyle/>
-          <a:p>
-            <a:pPr algn="l" indent="0" marL="0">
-              <a:buNone/>
-            </a:pPr>
-            <a:r>
-              <a:rPr lang="en-US" sz="3000" b="1" dirty="0">
-                <a:solidFill>
-                  <a:schemeClr val="tx2"/>
-                </a:solidFill>
-              </a:rPr>
               <a:t>Hosted demo, live extraction proof and source code</a:t>
             </a:r>
             <a:endParaRPr lang="en-US" sz="3000" dirty="0"/>
@@ -5010,7 +4320,7 @@
             <a:pPr algn="r"/>
             <a:fld id="{F7021451-1387-4CA6-816F-3879F97B5CBC}" type="slidenum">
               <a:rPr b="0" lang="en-US"/>
-              <a:t>4</a:t>
+              <a:t>3</a:t>
             </a:fld>
             <a:endParaRPr lang="en-US"/>
           </a:p>

</xml_diff>

<commit_message>
Repo polish: README, self-contained deck build, dead files removed
- README rewritten: live links, data caveat, architecture diagram, quick
  start, data and value model, trial-org notes and known limits
- Deck theme applied by deck/theme.js (no machine-specific path);
  npm run build builds both decks
- Remove the superseded build_dashboard.py and unused images

Co-Authored-By: Claude Opus 5.5 <noreply@anthropic.com>
</commit_message>
<xml_diff>
--- a/deck/salesforce-process-intelligence-tech-setup.pptx
+++ b/deck/salesforce-process-intelligence-tech-setup.pptx
@@ -109,7 +109,7 @@
   <p:extLst>
     <p:ext uri="{521415D9-36F7-43E2-AB2F-B90AF26B5E84}">
       <p14:sectionLst xmlns:p14="http://schemas.microsoft.com/office/powerpoint/2010/main">
-        <p14:section name="Tech setup" id="{4fdea6c2-f935-2ca6-1ebd-0ecd4283696d}">
+        <p14:section name="Tech setup" id="{1e391034-50e4-c5ad-5d1b-ae27274b2348}">
           <p14:sldIdLst>
             <p14:sldId id="256"/>
             <p14:sldId id="257"/>
@@ -4335,9 +4335,9 @@
 </file>
 
 <file path=ppt/theme/theme1.xml><?xml version="1.0" encoding="utf-8"?>
-<a:theme xmlns:a="http://schemas.openxmlformats.org/drawingml/2006/main" name="Salesforce Handbook">
+<a:theme xmlns:a="http://schemas.openxmlformats.org/drawingml/2006/main" name="Process Intelligence">
   <a:themeElements>
-    <a:clrScheme name="Salesforce Handbook">
+    <a:clrScheme name="Process Intelligence">
       <a:dk1>
         <a:srgbClr val="181818"/>
       </a:dk1>
@@ -4375,7 +4375,7 @@
         <a:srgbClr val="032D60"/>
       </a:folHlink>
     </a:clrScheme>
-    <a:fontScheme name="Salesforce Handbook">
+    <a:fontScheme name="Process Intelligence">
       <a:majorFont>
         <a:latin typeface="Arial"/>
         <a:ea typeface=""/>

</xml_diff>